<commit_message>
Add actual dashboard screenshot to user guide PPTX
- Embedded screenshot of dashboard homepage on slide 2
- 11 slides with mixed actual screenshot + ASCII mockups
- Screenshots captured via Firefox headless
</commit_message>
<xml_diff>
--- a/Module_ELC_Yield_User_Guide.pptx
+++ b/Module_ELC_Yield_User_Guide.pptx
@@ -16,7 +16,6 @@
     <p:sldId id="264" r:id="rId15"/>
     <p:sldId id="265" r:id="rId16"/>
     <p:sldId id="266" r:id="rId17"/>
-    <p:sldId id="267" r:id="rId18"/>
   </p:sldIdLst>
   <p:sldSz cx="12191695" cy="6858000" type="screen4x3"/>
   <p:notesSz cx="6858000" cy="9144000"/>
@@ -3186,6 +3185,10 @@
             <a:r>
               <a:t>Step-by-Step User Guide</a:t>
             </a:r>
+            <a:br/>
+            <a:r>
+              <a:t>April 2026</a:t>
+            </a:r>
           </a:p>
         </p:txBody>
       </p:sp>
@@ -3216,7 +3219,7 @@
         <p:spPr>
           <a:xfrm>
             <a:off x="0" y="0"/>
-            <a:ext cx="12191695" cy="1097280"/>
+            <a:ext cx="12191695" cy="914400"/>
           </a:xfrm>
           <a:prstGeom prst="rect">
             <a:avLst/>
@@ -3258,8 +3261,8 @@
         </p:nvSpPr>
         <p:spPr>
           <a:xfrm>
-            <a:off x="457200" y="274320"/>
-            <a:ext cx="10972800" cy="731520"/>
+            <a:off x="457200" y="228600"/>
+            <a:ext cx="10972800" cy="548640"/>
           </a:xfrm>
           <a:prstGeom prst="rect">
             <a:avLst/>
@@ -3273,7 +3276,7 @@
           <a:lstStyle/>
           <a:p>
             <a:pPr>
-              <a:defRPr sz="3200" b="1">
+              <a:defRPr sz="2800" b="1">
                 <a:solidFill>
                   <a:srgbClr val="FFFFFF"/>
                 </a:solidFill>
@@ -3293,8 +3296,8 @@
         </p:nvSpPr>
         <p:spPr>
           <a:xfrm>
-            <a:off x="457200" y="1371600"/>
-            <a:ext cx="5029200" cy="5029200"/>
+            <a:off x="457200" y="1188720"/>
+            <a:ext cx="5029200" cy="5303520"/>
           </a:xfrm>
           <a:prstGeom prst="rect">
             <a:avLst/>
@@ -3309,7 +3312,7 @@
           <a:p>
             <a:pPr>
               <a:spcAft>
-                <a:spcPts val="1200"/>
+                <a:spcPts val="1000"/>
               </a:spcAft>
               <a:defRPr sz="1800">
                 <a:solidFill>
@@ -3324,49 +3327,34 @@
           <a:p>
             <a:pPr>
               <a:spcAft>
-                <a:spcPts val="1200"/>
-              </a:spcAft>
-              <a:defRPr sz="1800">
-                <a:solidFill>
-                  <a:srgbClr val="323232"/>
-                </a:solidFill>
-              </a:defRPr>
-            </a:pPr>
-            <a:r>
-              <a:t>these DID + Density + Speed</a:t>
-            </a:r>
-          </a:p>
-          <a:p>
-            <a:pPr>
-              <a:spcAft>
-                <a:spcPts val="1200"/>
-              </a:spcAft>
-              <a:defRPr sz="1800">
-                <a:solidFill>
-                  <a:srgbClr val="323232"/>
-                </a:solidFill>
-              </a:defRPr>
-            </a:pPr>
-            <a:r>
-              <a:t>combinations:</a:t>
-            </a:r>
-          </a:p>
-          <a:p>
-            <a:pPr>
-              <a:spcAft>
-                <a:spcPts val="1200"/>
-              </a:spcAft>
-              <a:defRPr sz="1800">
-                <a:solidFill>
-                  <a:srgbClr val="323232"/>
-                </a:solidFill>
-              </a:defRPr>
-            </a:pPr>
-          </a:p>
-          <a:p>
-            <a:pPr>
-              <a:spcAft>
-                <a:spcPts val="1200"/>
+                <a:spcPts val="1000"/>
+              </a:spcAft>
+              <a:defRPr sz="1800">
+                <a:solidFill>
+                  <a:srgbClr val="323232"/>
+                </a:solidFill>
+              </a:defRPr>
+            </a:pPr>
+            <a:r>
+              <a:t>these DID + Density + Speed:</a:t>
+            </a:r>
+          </a:p>
+          <a:p>
+            <a:pPr>
+              <a:spcAft>
+                <a:spcPts val="1000"/>
+              </a:spcAft>
+              <a:defRPr sz="1800">
+                <a:solidFill>
+                  <a:srgbClr val="323232"/>
+                </a:solidFill>
+              </a:defRPr>
+            </a:pPr>
+          </a:p>
+          <a:p>
+            <a:pPr>
+              <a:spcAft>
+                <a:spcPts val="1000"/>
               </a:spcAft>
               <a:defRPr sz="1800">
                 <a:solidFill>
@@ -3381,7 +3369,7 @@
           <a:p>
             <a:pPr>
               <a:spcAft>
-                <a:spcPts val="1200"/>
+                <a:spcPts val="1000"/>
               </a:spcAft>
               <a:defRPr sz="1800">
                 <a:solidFill>
@@ -3396,19 +3384,19 @@
           <a:p>
             <a:pPr>
               <a:spcAft>
-                <a:spcPts val="1200"/>
-              </a:spcAft>
-              <a:defRPr sz="1800">
-                <a:solidFill>
-                  <a:srgbClr val="323232"/>
-                </a:solidFill>
-              </a:defRPr>
-            </a:pPr>
-          </a:p>
-          <a:p>
-            <a:pPr>
-              <a:spcAft>
-                <a:spcPts val="1200"/>
+                <a:spcPts val="1000"/>
+              </a:spcAft>
+              <a:defRPr sz="1800">
+                <a:solidFill>
+                  <a:srgbClr val="323232"/>
+                </a:solidFill>
+              </a:defRPr>
+            </a:pPr>
+          </a:p>
+          <a:p>
+            <a:pPr>
+              <a:spcAft>
+                <a:spcPts val="1000"/>
               </a:spcAft>
               <a:defRPr sz="1800">
                 <a:solidFill>
@@ -3423,19 +3411,19 @@
           <a:p>
             <a:pPr>
               <a:spcAft>
-                <a:spcPts val="1200"/>
-              </a:spcAft>
-              <a:defRPr sz="1800">
-                <a:solidFill>
-                  <a:srgbClr val="323232"/>
-                </a:solidFill>
-              </a:defRPr>
-            </a:pPr>
-          </a:p>
-          <a:p>
-            <a:pPr>
-              <a:spcAft>
-                <a:spcPts val="1200"/>
+                <a:spcPts val="1000"/>
+              </a:spcAft>
+              <a:defRPr sz="1800">
+                <a:solidFill>
+                  <a:srgbClr val="323232"/>
+                </a:solidFill>
+              </a:defRPr>
+            </a:pPr>
+          </a:p>
+          <a:p>
+            <a:pPr>
+              <a:spcAft>
+                <a:spcPts val="1000"/>
               </a:spcAft>
               <a:defRPr sz="1800">
                 <a:solidFill>
@@ -3450,7 +3438,7 @@
           <a:p>
             <a:pPr>
               <a:spcAft>
-                <a:spcPts val="1200"/>
+                <a:spcPts val="1000"/>
               </a:spcAft>
               <a:defRPr sz="1800">
                 <a:solidFill>
@@ -3465,7 +3453,7 @@
           <a:p>
             <a:pPr>
               <a:spcAft>
-                <a:spcPts val="1200"/>
+                <a:spcPts val="1000"/>
               </a:spcAft>
               <a:defRPr sz="1800">
                 <a:solidFill>
@@ -3487,18 +3475,18 @@
         </p:nvSpPr>
         <p:spPr>
           <a:xfrm>
-            <a:off x="5943600" y="1371600"/>
-            <a:ext cx="5760720" cy="5029200"/>
+            <a:off x="5943600" y="1188720"/>
+            <a:ext cx="5760720" cy="5303520"/>
           </a:xfrm>
           <a:prstGeom prst="roundRect">
             <a:avLst/>
           </a:prstGeom>
           <a:solidFill>
-            <a:srgbClr val="F0F0F0"/>
+            <a:srgbClr val="F5F5F5"/>
           </a:solidFill>
           <a:ln>
             <a:solidFill>
-              <a:srgbClr val="969696"/>
+              <a:srgbClr val="B4B4B4"/>
             </a:solidFill>
           </a:ln>
         </p:spPr>
@@ -3532,8 +3520,8 @@
         </p:nvSpPr>
         <p:spPr>
           <a:xfrm>
-            <a:off x="6126480" y="1554480"/>
-            <a:ext cx="5394960" cy="4663440"/>
+            <a:off x="6126480" y="1371600"/>
+            <a:ext cx="5394960" cy="4937760"/>
           </a:xfrm>
           <a:prstGeom prst="rect">
             <a:avLst/>
@@ -3616,10 +3604,6 @@
             <a:br/>
             <a:r>
               <a:t>│         (Starts Apr'27)                         │</a:t>
-            </a:r>
-            <a:br/>
-            <a:r>
-              <a:t>│                                                 │</a:t>
             </a:r>
             <a:br/>
             <a:r>
@@ -3655,7 +3639,7 @@
         <p:spPr>
           <a:xfrm>
             <a:off x="0" y="0"/>
-            <a:ext cx="12191695" cy="1097280"/>
+            <a:ext cx="12191695" cy="914400"/>
           </a:xfrm>
           <a:prstGeom prst="rect">
             <a:avLst/>
@@ -3697,8 +3681,8 @@
         </p:nvSpPr>
         <p:spPr>
           <a:xfrm>
-            <a:off x="457200" y="274320"/>
-            <a:ext cx="10972800" cy="731520"/>
+            <a:off x="457200" y="228600"/>
+            <a:ext cx="10972800" cy="548640"/>
           </a:xfrm>
           <a:prstGeom prst="rect">
             <a:avLst/>
@@ -3712,14 +3696,14 @@
           <a:lstStyle/>
           <a:p>
             <a:pPr>
-              <a:defRPr sz="3200" b="1">
+              <a:defRPr sz="2800" b="1">
                 <a:solidFill>
                   <a:srgbClr val="FFFFFF"/>
                 </a:solidFill>
               </a:defRPr>
             </a:pPr>
             <a:r>
-              <a:t>Pro Tips</a:t>
+              <a:t>Quick Reference</a:t>
             </a:r>
           </a:p>
         </p:txBody>
@@ -3732,8 +3716,8 @@
         </p:nvSpPr>
         <p:spPr>
           <a:xfrm>
-            <a:off x="457200" y="1371600"/>
-            <a:ext cx="11277295" cy="5029200"/>
+            <a:off x="457200" y="1188720"/>
+            <a:ext cx="5029200" cy="5303520"/>
           </a:xfrm>
           <a:prstGeom prst="rect">
             <a:avLst/>
@@ -3748,226 +3732,299 @@
           <a:p>
             <a:pPr>
               <a:spcAft>
-                <a:spcPts val="1200"/>
-              </a:spcAft>
-              <a:defRPr sz="1800">
-                <a:solidFill>
-                  <a:srgbClr val="323232"/>
-                </a:solidFill>
-              </a:defRPr>
-            </a:pPr>
-            <a:r>
-              <a:t>💡 Quick Reference:</a:t>
-            </a:r>
-          </a:p>
-          <a:p>
-            <a:pPr>
-              <a:spcAft>
-                <a:spcPts val="1200"/>
-              </a:spcAft>
-              <a:defRPr sz="1800">
-                <a:solidFill>
-                  <a:srgbClr val="323232"/>
-                </a:solidFill>
-              </a:defRPr>
-            </a:pPr>
-          </a:p>
-          <a:p>
-            <a:pPr>
-              <a:spcAft>
-                <a:spcPts val="1200"/>
-              </a:spcAft>
-              <a:defRPr sz="1800">
-                <a:solidFill>
-                  <a:srgbClr val="323232"/>
-                </a:solidFill>
-              </a:defRPr>
-            </a:pPr>
-            <a:r>
-              <a:t>1. Always start with narrow filters</a:t>
-            </a:r>
-          </a:p>
-          <a:p>
-            <a:pPr>
-              <a:spcAft>
-                <a:spcPts val="1200"/>
-              </a:spcAft>
-              <a:defRPr sz="1800">
-                <a:solidFill>
-                  <a:srgbClr val="323232"/>
-                </a:solidFill>
-              </a:defRPr>
-            </a:pPr>
-            <a:r>
-              <a:t>   (single DID, single form factor)</a:t>
-            </a:r>
-          </a:p>
-          <a:p>
-            <a:pPr>
-              <a:spcAft>
-                <a:spcPts val="1200"/>
-              </a:spcAft>
-              <a:defRPr sz="1800">
-                <a:solidFill>
-                  <a:srgbClr val="323232"/>
-                </a:solidFill>
-              </a:defRPr>
-            </a:pPr>
-          </a:p>
-          <a:p>
-            <a:pPr>
-              <a:spcAft>
-                <a:spcPts val="1200"/>
-              </a:spcAft>
-              <a:defRPr sz="1800">
-                <a:solidFill>
-                  <a:srgbClr val="323232"/>
-                </a:solidFill>
-              </a:defRPr>
-            </a:pPr>
-            <a:r>
-              <a:t>2. Select all 3 steps (HMFN, SLT, ELC)</a:t>
-            </a:r>
-          </a:p>
-          <a:p>
-            <a:pPr>
-              <a:spcAft>
-                <a:spcPts val="1200"/>
-              </a:spcAft>
-              <a:defRPr sz="1800">
-                <a:solidFill>
-                  <a:srgbClr val="323232"/>
-                </a:solidFill>
-              </a:defRPr>
-            </a:pPr>
-            <a:r>
-              <a:t>   to see the complete yield flow</a:t>
-            </a:r>
-          </a:p>
-          <a:p>
-            <a:pPr>
-              <a:spcAft>
-                <a:spcPts val="1200"/>
-              </a:spcAft>
-              <a:defRPr sz="1800">
-                <a:solidFill>
-                  <a:srgbClr val="323232"/>
-                </a:solidFill>
-              </a:defRPr>
-            </a:pPr>
-          </a:p>
-          <a:p>
-            <a:pPr>
-              <a:spcAft>
-                <a:spcPts val="1200"/>
-              </a:spcAft>
-              <a:defRPr sz="1800">
-                <a:solidFill>
-                  <a:srgbClr val="323232"/>
-                </a:solidFill>
-              </a:defRPr>
-            </a:pPr>
-            <a:r>
-              <a:t>3. Use 'Select All' then uncheck</a:t>
-            </a:r>
-          </a:p>
-          <a:p>
-            <a:pPr>
-              <a:spcAft>
-                <a:spcPts val="1200"/>
-              </a:spcAft>
-              <a:defRPr sz="1800">
-                <a:solidFill>
-                  <a:srgbClr val="323232"/>
-                </a:solidFill>
-              </a:defRPr>
-            </a:pPr>
-            <a:r>
-              <a:t>   unwanted configs</a:t>
-            </a:r>
-          </a:p>
-          <a:p>
-            <a:pPr>
-              <a:spcAft>
-                <a:spcPts val="1200"/>
-              </a:spcAft>
-              <a:defRPr sz="1800">
-                <a:solidFill>
-                  <a:srgbClr val="323232"/>
-                </a:solidFill>
-              </a:defRPr>
-            </a:pPr>
-          </a:p>
-          <a:p>
-            <a:pPr>
-              <a:spcAft>
-                <a:spcPts val="1200"/>
-              </a:spcAft>
-              <a:defRPr sz="1800">
-                <a:solidFill>
-                  <a:srgbClr val="323232"/>
-                </a:solidFill>
-              </a:defRPr>
-            </a:pPr>
-            <a:r>
-              <a:t>4. Hover over chart points for</a:t>
-            </a:r>
-          </a:p>
-          <a:p>
-            <a:pPr>
-              <a:spcAft>
-                <a:spcPts val="1200"/>
-              </a:spcAft>
-              <a:defRPr sz="1800">
-                <a:solidFill>
-                  <a:srgbClr val="323232"/>
-                </a:solidFill>
-              </a:defRPr>
-            </a:pPr>
-            <a:r>
-              <a:t>   exact yield values</a:t>
-            </a:r>
-          </a:p>
-          <a:p>
-            <a:pPr>
-              <a:spcAft>
-                <a:spcPts val="1200"/>
-              </a:spcAft>
-              <a:defRPr sz="1800">
-                <a:solidFill>
-                  <a:srgbClr val="323232"/>
-                </a:solidFill>
-              </a:defRPr>
-            </a:pPr>
-          </a:p>
-          <a:p>
-            <a:pPr>
-              <a:spcAft>
-                <a:spcPts val="1200"/>
-              </a:spcAft>
-              <a:defRPr sz="1800">
-                <a:solidFill>
-                  <a:srgbClr val="323232"/>
-                </a:solidFill>
-              </a:defRPr>
-            </a:pPr>
-            <a:r>
-              <a:t>5. Use 4-week rolling average</a:t>
-            </a:r>
-          </a:p>
-          <a:p>
-            <a:pPr>
-              <a:spcAft>
-                <a:spcPts val="1200"/>
-              </a:spcAft>
-              <a:defRPr sz="1800">
-                <a:solidFill>
-                  <a:srgbClr val="323232"/>
-                </a:solidFill>
-              </a:defRPr>
-            </a:pPr>
-            <a:r>
-              <a:t>   to smooth out weekly noise</a:t>
+                <a:spcPts val="1000"/>
+              </a:spcAft>
+              <a:defRPr sz="1800">
+                <a:solidFill>
+                  <a:srgbClr val="323232"/>
+                </a:solidFill>
+              </a:defRPr>
+            </a:pPr>
+            <a:r>
+              <a:t>Dashboard URL:</a:t>
+            </a:r>
+          </a:p>
+          <a:p>
+            <a:pPr>
+              <a:spcAft>
+                <a:spcPts val="1000"/>
+              </a:spcAft>
+              <a:defRPr sz="1800">
+                <a:solidFill>
+                  <a:srgbClr val="323232"/>
+                </a:solidFill>
+              </a:defRPr>
+            </a:pPr>
+            <a:r>
+              <a:t>http://bolpedh03.micron.com:8502</a:t>
+            </a:r>
+          </a:p>
+          <a:p>
+            <a:pPr>
+              <a:spcAft>
+                <a:spcPts val="1000"/>
+              </a:spcAft>
+              <a:defRPr sz="1800">
+                <a:solidFill>
+                  <a:srgbClr val="323232"/>
+                </a:solidFill>
+              </a:defRPr>
+            </a:pPr>
+          </a:p>
+          <a:p>
+            <a:pPr>
+              <a:spcAft>
+                <a:spcPts val="1000"/>
+              </a:spcAft>
+              <a:defRPr sz="1800">
+                <a:solidFill>
+                  <a:srgbClr val="323232"/>
+                </a:solidFill>
+              </a:defRPr>
+            </a:pPr>
+            <a:r>
+              <a:t>Key Contact:</a:t>
+            </a:r>
+          </a:p>
+          <a:p>
+            <a:pPr>
+              <a:spcAft>
+                <a:spcPts val="1000"/>
+              </a:spcAft>
+              <a:defRPr sz="1800">
+                <a:solidFill>
+                  <a:srgbClr val="323232"/>
+                </a:solidFill>
+              </a:defRPr>
+            </a:pPr>
+            <a:r>
+              <a:t>Asegaran (Dashboard Owner)</a:t>
+            </a:r>
+          </a:p>
+          <a:p>
+            <a:pPr>
+              <a:spcAft>
+                <a:spcPts val="1000"/>
+              </a:spcAft>
+              <a:defRPr sz="1800">
+                <a:solidFill>
+                  <a:srgbClr val="323232"/>
+                </a:solidFill>
+              </a:defRPr>
+            </a:pPr>
+          </a:p>
+          <a:p>
+            <a:pPr>
+              <a:spcAft>
+                <a:spcPts val="1000"/>
+              </a:spcAft>
+              <a:defRPr sz="1800">
+                <a:solidFill>
+                  <a:srgbClr val="323232"/>
+                </a:solidFill>
+              </a:defRPr>
+            </a:pPr>
+            <a:r>
+              <a:t>Data Source:</a:t>
+            </a:r>
+          </a:p>
+          <a:p>
+            <a:pPr>
+              <a:spcAft>
+                <a:spcPts val="1000"/>
+              </a:spcAft>
+              <a:defRPr sz="1800">
+                <a:solidFill>
+                  <a:srgbClr val="323232"/>
+                </a:solidFill>
+              </a:defRPr>
+            </a:pPr>
+            <a:r>
+              <a:t>frpt/mtsums commands</a:t>
+            </a:r>
+          </a:p>
+          <a:p>
+            <a:pPr>
+              <a:spcAft>
+                <a:spcPts val="1000"/>
+              </a:spcAft>
+              <a:defRPr sz="1800">
+                <a:solidFill>
+                  <a:srgbClr val="323232"/>
+                </a:solidFill>
+              </a:defRPr>
+            </a:pPr>
+          </a:p>
+          <a:p>
+            <a:pPr>
+              <a:spcAft>
+                <a:spcPts val="1000"/>
+              </a:spcAft>
+              <a:defRPr sz="1800">
+                <a:solidFill>
+                  <a:srgbClr val="323232"/>
+                </a:solidFill>
+              </a:defRPr>
+            </a:pPr>
+            <a:r>
+              <a:t>Last Updated: April 2026</a:t>
+            </a:r>
+          </a:p>
+        </p:txBody>
+      </p:sp>
+      <p:sp>
+        <p:nvSpPr>
+          <p:cNvPr id="5" name="Rounded Rectangle 4"/>
+          <p:cNvSpPr/>
+          <p:nvPr/>
+        </p:nvSpPr>
+        <p:spPr>
+          <a:xfrm>
+            <a:off x="5943600" y="1188720"/>
+            <a:ext cx="5760720" cy="5303520"/>
+          </a:xfrm>
+          <a:prstGeom prst="roundRect">
+            <a:avLst/>
+          </a:prstGeom>
+          <a:solidFill>
+            <a:srgbClr val="F5F5F5"/>
+          </a:solidFill>
+          <a:ln>
+            <a:solidFill>
+              <a:srgbClr val="B4B4B4"/>
+            </a:solidFill>
+          </a:ln>
+        </p:spPr>
+        <p:style>
+          <a:lnRef idx="1">
+            <a:schemeClr val="accent1"/>
+          </a:lnRef>
+          <a:fillRef idx="3">
+            <a:schemeClr val="accent1"/>
+          </a:fillRef>
+          <a:effectRef idx="2">
+            <a:schemeClr val="accent1"/>
+          </a:effectRef>
+          <a:fontRef idx="minor">
+            <a:schemeClr val="lt1"/>
+          </a:fontRef>
+        </p:style>
+        <p:txBody>
+          <a:bodyPr rtlCol="0" anchor="ctr"/>
+          <a:lstStyle/>
+          <a:p>
+            <a:pPr algn="ctr"/>
+          </a:p>
+        </p:txBody>
+      </p:sp>
+      <p:sp>
+        <p:nvSpPr>
+          <p:cNvPr id="6" name="TextBox 5"/>
+          <p:cNvSpPr txBox="1"/>
+          <p:nvPr/>
+        </p:nvSpPr>
+        <p:spPr>
+          <a:xfrm>
+            <a:off x="6126480" y="1371600"/>
+            <a:ext cx="5394960" cy="4937760"/>
+          </a:xfrm>
+          <a:prstGeom prst="rect">
+            <a:avLst/>
+          </a:prstGeom>
+          <a:noFill/>
+        </p:spPr>
+        <p:txBody>
+          <a:bodyPr wrap="square">
+            <a:spAutoFit/>
+          </a:bodyPr>
+          <a:lstStyle/>
+          <a:p>
+            <a:pPr>
+              <a:defRPr sz="1000">
+                <a:solidFill>
+                  <a:srgbClr val="323232"/>
+                </a:solidFill>
+                <a:latin typeface="Courier New"/>
+              </a:defRPr>
+            </a:pPr>
+            <a:r>
+              <a:t>┌─────────────────────────────────────────────────┐</a:t>
+            </a:r>
+            <a:br/>
+            <a:r>
+              <a:t>│            QUICK REFERENCE CARD                 │</a:t>
+            </a:r>
+            <a:br/>
+            <a:r>
+              <a:t>├─────────────────────────────────────────────────┤</a:t>
+            </a:r>
+            <a:br/>
+            <a:r>
+              <a:t>│  TARGET LINE COLORS:                            │</a:t>
+            </a:r>
+            <a:br/>
+            <a:r>
+              <a:t>│  ┄┄┄ Blue   = HMFN Target                      │</a:t>
+            </a:r>
+            <a:br/>
+            <a:r>
+              <a:t>│  ┄┄┄ Red    = SLT Target                       │</a:t>
+            </a:r>
+            <a:br/>
+            <a:r>
+              <a:t>│  ┄┄┄ Green  = ELC Target                       │</a:t>
+            </a:r>
+            <a:br/>
+            <a:r>
+              <a:t>│                                                 │</a:t>
+            </a:r>
+            <a:br/>
+            <a:r>
+              <a:t>│  YIELD CALCULATION:                             │</a:t>
+            </a:r>
+            <a:br/>
+            <a:r>
+              <a:t>│  ELC = HMFN × SLT                              │</a:t>
+            </a:r>
+            <a:br/>
+            <a:r>
+              <a:t>│  SLT = HMB1 × QMON                             │</a:t>
+            </a:r>
+            <a:br/>
+            <a:r>
+              <a:t>│                                                 │</a:t>
+            </a:r>
+            <a:br/>
+            <a:r>
+              <a:t>│  KEY TARGETS (Typical):                         │</a:t>
+            </a:r>
+            <a:br/>
+            <a:r>
+              <a:t>│  HMFN: 99% → 99.5%                             │</a:t>
+            </a:r>
+            <a:br/>
+            <a:r>
+              <a:t>│  SLT:  97% → 99%                               │</a:t>
+            </a:r>
+            <a:br/>
+            <a:r>
+              <a:t>│  ELC:  95.54% → 98.51%                         │</a:t>
+            </a:r>
+            <a:br/>
+            <a:r>
+              <a:t>│                                                 │</a:t>
+            </a:r>
+            <a:br/>
+            <a:r>
+              <a:t>│  TROUBLESHOOTING:                               │</a:t>
+            </a:r>
+            <a:br/>
+            <a:r>
+              <a:t>│  No targets? → Select single config            │</a:t>
+            </a:r>
+            <a:br/>
+            <a:r>
+              <a:t>└─────────────────────────────────────────────────┘</a:t>
             </a:r>
           </a:p>
         </p:txBody>
@@ -3980,7 +4037,7 @@
 </p:sld>
 </file>
 
-<file path=ppt/slides/slide12.xml><?xml version="1.0" encoding="utf-8"?>
+<file path=ppt/slides/slide2.xml><?xml version="1.0" encoding="utf-8"?>
 <p:sld xmlns:a="http://schemas.openxmlformats.org/drawingml/2006/main" xmlns:p="http://schemas.openxmlformats.org/presentationml/2006/main" xmlns:r="http://schemas.openxmlformats.org/officeDocument/2006/relationships">
   <p:cSld>
     <p:spTree>
@@ -3999,7 +4056,7 @@
         <p:spPr>
           <a:xfrm>
             <a:off x="0" y="0"/>
-            <a:ext cx="12191695" cy="1097280"/>
+            <a:ext cx="12191695" cy="731520"/>
           </a:xfrm>
           <a:prstGeom prst="rect">
             <a:avLst/>
@@ -4041,8 +4098,8 @@
         </p:nvSpPr>
         <p:spPr>
           <a:xfrm>
-            <a:off x="457200" y="274320"/>
-            <a:ext cx="10972800" cy="731520"/>
+            <a:off x="274320" y="137160"/>
+            <a:ext cx="10972800" cy="548640"/>
           </a:xfrm>
           <a:prstGeom prst="rect">
             <a:avLst/>
@@ -4056,28 +4113,52 @@
           <a:lstStyle/>
           <a:p>
             <a:pPr>
-              <a:defRPr sz="3200" b="1">
+              <a:defRPr sz="2800" b="1">
                 <a:solidFill>
                   <a:srgbClr val="FFFFFF"/>
                 </a:solidFill>
               </a:defRPr>
             </a:pPr>
             <a:r>
-              <a:t>Quick Reference Card</a:t>
-            </a:r>
-          </a:p>
-        </p:txBody>
-      </p:sp>
-      <p:sp>
-        <p:nvSpPr>
-          <p:cNvPr id="4" name="TextBox 3"/>
+              <a:t>Dashboard Overview</a:t>
+            </a:r>
+          </a:p>
+        </p:txBody>
+      </p:sp>
+      <p:pic>
+        <p:nvPicPr>
+          <p:cNvPr id="4" name="Picture 3" descr="dash_home.png"/>
+          <p:cNvPicPr>
+            <a:picLocks noChangeAspect="1"/>
+          </p:cNvPicPr>
+          <p:nvPr/>
+        </p:nvPicPr>
+        <p:blipFill>
+          <a:blip r:embed="rId2"/>
+          <a:stretch>
+            <a:fillRect/>
+          </a:stretch>
+        </p:blipFill>
+        <p:spPr>
+          <a:xfrm>
+            <a:off x="380847" y="914400"/>
+            <a:ext cx="11430000" cy="5303520"/>
+          </a:xfrm>
+          <a:prstGeom prst="rect">
+            <a:avLst/>
+          </a:prstGeom>
+        </p:spPr>
+      </p:pic>
+      <p:sp>
+        <p:nvSpPr>
+          <p:cNvPr id="5" name="TextBox 4"/>
           <p:cNvSpPr txBox="1"/>
           <p:nvPr/>
         </p:nvSpPr>
         <p:spPr>
           <a:xfrm>
-            <a:off x="457200" y="1371600"/>
-            <a:ext cx="5029200" cy="5029200"/>
+            <a:off x="457200" y="6400800"/>
+            <a:ext cx="11277295" cy="365760"/>
           </a:xfrm>
           <a:prstGeom prst="rect">
             <a:avLst/>
@@ -4085,341 +4166,20 @@
           <a:noFill/>
         </p:spPr>
         <p:txBody>
-          <a:bodyPr wrap="square">
+          <a:bodyPr wrap="none">
             <a:spAutoFit/>
           </a:bodyPr>
           <a:lstStyle/>
           <a:p>
-            <a:pPr>
-              <a:spcAft>
-                <a:spcPts val="1200"/>
-              </a:spcAft>
-              <a:defRPr sz="1800">
-                <a:solidFill>
-                  <a:srgbClr val="323232"/>
-                </a:solidFill>
-              </a:defRPr>
-            </a:pPr>
-            <a:r>
-              <a:t>Bookmark this slide!</a:t>
-            </a:r>
-          </a:p>
-          <a:p>
-            <a:pPr>
-              <a:spcAft>
-                <a:spcPts val="1200"/>
-              </a:spcAft>
-              <a:defRPr sz="1800">
-                <a:solidFill>
-                  <a:srgbClr val="323232"/>
-                </a:solidFill>
-              </a:defRPr>
-            </a:pPr>
-          </a:p>
-          <a:p>
-            <a:pPr>
-              <a:spcAft>
-                <a:spcPts val="1200"/>
-              </a:spcAft>
-              <a:defRPr sz="1800">
-                <a:solidFill>
-                  <a:srgbClr val="323232"/>
-                </a:solidFill>
-              </a:defRPr>
-            </a:pPr>
-            <a:r>
-              <a:t>Dashboard URL:</a:t>
-            </a:r>
-          </a:p>
-          <a:p>
-            <a:pPr>
-              <a:spcAft>
-                <a:spcPts val="1200"/>
-              </a:spcAft>
-              <a:defRPr sz="1800">
-                <a:solidFill>
-                  <a:srgbClr val="323232"/>
-                </a:solidFill>
-              </a:defRPr>
-            </a:pPr>
-            <a:r>
-              <a:t>http://bolpedh03.micron.com:8502</a:t>
-            </a:r>
-          </a:p>
-          <a:p>
-            <a:pPr>
-              <a:spcAft>
-                <a:spcPts val="1200"/>
-              </a:spcAft>
-              <a:defRPr sz="1800">
-                <a:solidFill>
-                  <a:srgbClr val="323232"/>
-                </a:solidFill>
-              </a:defRPr>
-            </a:pPr>
-          </a:p>
-          <a:p>
-            <a:pPr>
-              <a:spcAft>
-                <a:spcPts val="1200"/>
-              </a:spcAft>
-              <a:defRPr sz="1800">
-                <a:solidFill>
-                  <a:srgbClr val="323232"/>
-                </a:solidFill>
-              </a:defRPr>
-            </a:pPr>
-            <a:r>
-              <a:t>Key Contact:</a:t>
-            </a:r>
-          </a:p>
-          <a:p>
-            <a:pPr>
-              <a:spcAft>
-                <a:spcPts val="1200"/>
-              </a:spcAft>
-              <a:defRPr sz="1800">
-                <a:solidFill>
-                  <a:srgbClr val="323232"/>
-                </a:solidFill>
-              </a:defRPr>
-            </a:pPr>
-            <a:r>
-              <a:t>Asegaran (Dashboard Owner)</a:t>
-            </a:r>
-          </a:p>
-          <a:p>
-            <a:pPr>
-              <a:spcAft>
-                <a:spcPts val="1200"/>
-              </a:spcAft>
-              <a:defRPr sz="1800">
-                <a:solidFill>
-                  <a:srgbClr val="323232"/>
-                </a:solidFill>
-              </a:defRPr>
-            </a:pPr>
-          </a:p>
-          <a:p>
-            <a:pPr>
-              <a:spcAft>
-                <a:spcPts val="1200"/>
-              </a:spcAft>
-              <a:defRPr sz="1800">
-                <a:solidFill>
-                  <a:srgbClr val="323232"/>
-                </a:solidFill>
-              </a:defRPr>
-            </a:pPr>
-            <a:r>
-              <a:t>Data Source:</a:t>
-            </a:r>
-          </a:p>
-          <a:p>
-            <a:pPr>
-              <a:spcAft>
-                <a:spcPts val="1200"/>
-              </a:spcAft>
-              <a:defRPr sz="1800">
-                <a:solidFill>
-                  <a:srgbClr val="323232"/>
-                </a:solidFill>
-              </a:defRPr>
-            </a:pPr>
-            <a:r>
-              <a:t>frpt/mtsums commands</a:t>
-            </a:r>
-          </a:p>
-          <a:p>
-            <a:pPr>
-              <a:spcAft>
-                <a:spcPts val="1200"/>
-              </a:spcAft>
-              <a:defRPr sz="1800">
-                <a:solidFill>
-                  <a:srgbClr val="323232"/>
-                </a:solidFill>
-              </a:defRPr>
-            </a:pPr>
-          </a:p>
-          <a:p>
-            <a:pPr>
-              <a:spcAft>
-                <a:spcPts val="1200"/>
-              </a:spcAft>
-              <a:defRPr sz="1800">
-                <a:solidFill>
-                  <a:srgbClr val="323232"/>
-                </a:solidFill>
-              </a:defRPr>
-            </a:pPr>
-            <a:r>
-              <a:t>Last Updated: Apr 2026</a:t>
-            </a:r>
-          </a:p>
-        </p:txBody>
-      </p:sp>
-      <p:sp>
-        <p:nvSpPr>
-          <p:cNvPr id="5" name="Rounded Rectangle 4"/>
-          <p:cNvSpPr/>
-          <p:nvPr/>
-        </p:nvSpPr>
-        <p:spPr>
-          <a:xfrm>
-            <a:off x="5943600" y="1371600"/>
-            <a:ext cx="5760720" cy="5029200"/>
-          </a:xfrm>
-          <a:prstGeom prst="roundRect">
-            <a:avLst/>
-          </a:prstGeom>
-          <a:solidFill>
-            <a:srgbClr val="F0F0F0"/>
-          </a:solidFill>
-          <a:ln>
-            <a:solidFill>
-              <a:srgbClr val="969696"/>
-            </a:solidFill>
-          </a:ln>
-        </p:spPr>
-        <p:style>
-          <a:lnRef idx="1">
-            <a:schemeClr val="accent1"/>
-          </a:lnRef>
-          <a:fillRef idx="3">
-            <a:schemeClr val="accent1"/>
-          </a:fillRef>
-          <a:effectRef idx="2">
-            <a:schemeClr val="accent1"/>
-          </a:effectRef>
-          <a:fontRef idx="minor">
-            <a:schemeClr val="lt1"/>
-          </a:fontRef>
-        </p:style>
-        <p:txBody>
-          <a:bodyPr rtlCol="0" anchor="ctr"/>
-          <a:lstStyle/>
-          <a:p>
-            <a:pPr algn="ctr"/>
-          </a:p>
-        </p:txBody>
-      </p:sp>
-      <p:sp>
-        <p:nvSpPr>
-          <p:cNvPr id="6" name="TextBox 5"/>
-          <p:cNvSpPr txBox="1"/>
-          <p:nvPr/>
-        </p:nvSpPr>
-        <p:spPr>
-          <a:xfrm>
-            <a:off x="6126480" y="1554480"/>
-            <a:ext cx="5394960" cy="4663440"/>
-          </a:xfrm>
-          <a:prstGeom prst="rect">
-            <a:avLst/>
-          </a:prstGeom>
-          <a:noFill/>
-        </p:spPr>
-        <p:txBody>
-          <a:bodyPr wrap="square">
-            <a:spAutoFit/>
-          </a:bodyPr>
-          <a:lstStyle/>
-          <a:p>
-            <a:pPr>
-              <a:defRPr sz="1000">
-                <a:solidFill>
-                  <a:srgbClr val="323232"/>
-                </a:solidFill>
-                <a:latin typeface="Courier New"/>
-              </a:defRPr>
-            </a:pPr>
-            <a:r>
-              <a:t>┌─────────────────────────────────────────────────┐</a:t>
-            </a:r>
-            <a:br/>
-            <a:r>
-              <a:t>│            QUICK REFERENCE CARD                 │</a:t>
-            </a:r>
-            <a:br/>
-            <a:r>
-              <a:t>├─────────────────────────────────────────────────┤</a:t>
-            </a:r>
-            <a:br/>
-            <a:r>
-              <a:t>│                                                 │</a:t>
-            </a:r>
-            <a:br/>
-            <a:r>
-              <a:t>│  TARGET LINE COLORS:                            │</a:t>
-            </a:r>
-            <a:br/>
-            <a:r>
-              <a:t>│  ┄┄┄ Blue   = HMFN Target                      │</a:t>
-            </a:r>
-            <a:br/>
-            <a:r>
-              <a:t>│  ┄┄┄ Red    = SLT Target                       │</a:t>
-            </a:r>
-            <a:br/>
-            <a:r>
-              <a:t>│  ┄┄┄ Green  = ELC Target                       │</a:t>
-            </a:r>
-            <a:br/>
-            <a:r>
-              <a:t>│                                                 │</a:t>
-            </a:r>
-            <a:br/>
-            <a:r>
-              <a:t>│  YIELD CALCULATION:                             │</a:t>
-            </a:r>
-            <a:br/>
-            <a:r>
-              <a:t>│  ELC = HMFN × SLT                              │</a:t>
-            </a:r>
-            <a:br/>
-            <a:r>
-              <a:t>│  SLT = HMB1 × QMON                             │</a:t>
-            </a:r>
-            <a:br/>
-            <a:r>
-              <a:t>│                                                 │</a:t>
-            </a:r>
-            <a:br/>
-            <a:r>
-              <a:t>│  KEY TARGETS (Typical):                         │</a:t>
-            </a:r>
-            <a:br/>
-            <a:r>
-              <a:t>│  HMFN: 99% → 99.5%                             │</a:t>
-            </a:r>
-            <a:br/>
-            <a:r>
-              <a:t>│  SLT:  97% → 99%                               │</a:t>
-            </a:r>
-            <a:br/>
-            <a:r>
-              <a:t>│  ELC:  95.54% → 98.51%                         │</a:t>
-            </a:r>
-            <a:br/>
-            <a:r>
-              <a:t>│                                                 │</a:t>
-            </a:r>
-            <a:br/>
-            <a:r>
-              <a:t>│  TROUBLESHOOTING:                               │</a:t>
-            </a:r>
-            <a:br/>
-            <a:r>
-              <a:t>│  No targets? → Select single config            │</a:t>
-            </a:r>
-            <a:br/>
-            <a:r>
-              <a:t>│  Warning? → Configs don't match                │</a:t>
-            </a:r>
-            <a:br/>
-            <a:r>
-              <a:t>└─────────────────────────────────────────────────┘</a:t>
+            <a:pPr algn="ctr">
+              <a:defRPr sz="1400">
+                <a:solidFill>
+                  <a:srgbClr val="646464"/>
+                </a:solidFill>
+              </a:defRPr>
+            </a:pPr>
+            <a:r>
+              <a:t>Module Yield Dashboard - http://bolpedh03.micron.com:8502</a:t>
             </a:r>
           </a:p>
         </p:txBody>
@@ -4432,7 +4192,7 @@
 </p:sld>
 </file>
 
-<file path=ppt/slides/slide2.xml><?xml version="1.0" encoding="utf-8"?>
+<file path=ppt/slides/slide3.xml><?xml version="1.0" encoding="utf-8"?>
 <p:sld xmlns:a="http://schemas.openxmlformats.org/drawingml/2006/main" xmlns:p="http://schemas.openxmlformats.org/presentationml/2006/main" xmlns:r="http://schemas.openxmlformats.org/officeDocument/2006/relationships">
   <p:cSld>
     <p:spTree>
@@ -4451,7 +4211,7 @@
         <p:spPr>
           <a:xfrm>
             <a:off x="0" y="0"/>
-            <a:ext cx="12191695" cy="1097280"/>
+            <a:ext cx="12191695" cy="914400"/>
           </a:xfrm>
           <a:prstGeom prst="rect">
             <a:avLst/>
@@ -4493,8 +4253,8 @@
         </p:nvSpPr>
         <p:spPr>
           <a:xfrm>
-            <a:off x="457200" y="274320"/>
-            <a:ext cx="10972800" cy="731520"/>
+            <a:off x="457200" y="228600"/>
+            <a:ext cx="10972800" cy="548640"/>
           </a:xfrm>
           <a:prstGeom prst="rect">
             <a:avLst/>
@@ -4508,7 +4268,7 @@
           <a:lstStyle/>
           <a:p>
             <a:pPr>
-              <a:defRPr sz="3200" b="1">
+              <a:defRPr sz="2800" b="1">
                 <a:solidFill>
                   <a:srgbClr val="FFFFFF"/>
                 </a:solidFill>
@@ -4528,8 +4288,8 @@
         </p:nvSpPr>
         <p:spPr>
           <a:xfrm>
-            <a:off x="457200" y="1371600"/>
-            <a:ext cx="11277295" cy="5029200"/>
+            <a:off x="457200" y="1188720"/>
+            <a:ext cx="11277295" cy="5303520"/>
           </a:xfrm>
           <a:prstGeom prst="rect">
             <a:avLst/>
@@ -4544,7 +4304,7 @@
           <a:p>
             <a:pPr>
               <a:spcAft>
-                <a:spcPts val="1200"/>
+                <a:spcPts val="1000"/>
               </a:spcAft>
               <a:defRPr sz="1800">
                 <a:solidFill>
@@ -4559,19 +4319,19 @@
           <a:p>
             <a:pPr>
               <a:spcAft>
-                <a:spcPts val="1200"/>
-              </a:spcAft>
-              <a:defRPr sz="1800">
-                <a:solidFill>
-                  <a:srgbClr val="323232"/>
-                </a:solidFill>
-              </a:defRPr>
-            </a:pPr>
-          </a:p>
-          <a:p>
-            <a:pPr>
-              <a:spcAft>
-                <a:spcPts val="1200"/>
+                <a:spcPts val="1000"/>
+              </a:spcAft>
+              <a:defRPr sz="1800">
+                <a:solidFill>
+                  <a:srgbClr val="323232"/>
+                </a:solidFill>
+              </a:defRPr>
+            </a:pPr>
+          </a:p>
+          <a:p>
+            <a:pPr>
+              <a:spcAft>
+                <a:spcPts val="1000"/>
               </a:spcAft>
               <a:defRPr sz="1800">
                 <a:solidFill>
@@ -4586,22 +4346,22 @@
           <a:p>
             <a:pPr>
               <a:spcAft>
-                <a:spcPts val="1200"/>
-              </a:spcAft>
-              <a:defRPr sz="1800">
-                <a:solidFill>
-                  <a:srgbClr val="323232"/>
-                </a:solidFill>
-              </a:defRPr>
-            </a:pPr>
-            <a:r>
-              <a:t>   • Multi-series yield comparison across configs</a:t>
-            </a:r>
-          </a:p>
-          <a:p>
-            <a:pPr>
-              <a:spcAft>
-                <a:spcPts val="1200"/>
+                <a:spcPts val="1000"/>
+              </a:spcAft>
+              <a:defRPr sz="1800">
+                <a:solidFill>
+                  <a:srgbClr val="323232"/>
+                </a:solidFill>
+              </a:defRPr>
+            </a:pPr>
+            <a:r>
+              <a:t>   • Multi-series yield comparison across configurations</a:t>
+            </a:r>
+          </a:p>
+          <a:p>
+            <a:pPr>
+              <a:spcAft>
+                <a:spcPts val="1000"/>
               </a:spcAft>
               <a:defRPr sz="1800">
                 <a:solidFill>
@@ -4616,7 +4376,7 @@
           <a:p>
             <a:pPr>
               <a:spcAft>
-                <a:spcPts val="1200"/>
+                <a:spcPts val="1000"/>
               </a:spcAft>
               <a:defRPr sz="1800">
                 <a:solidFill>
@@ -4631,7 +4391,7 @@
           <a:p>
             <a:pPr>
               <a:spcAft>
-                <a:spcPts val="1200"/>
+                <a:spcPts val="1000"/>
               </a:spcAft>
               <a:defRPr sz="1800">
                 <a:solidFill>
@@ -4646,19 +4406,19 @@
           <a:p>
             <a:pPr>
               <a:spcAft>
-                <a:spcPts val="1200"/>
-              </a:spcAft>
-              <a:defRPr sz="1800">
-                <a:solidFill>
-                  <a:srgbClr val="323232"/>
-                </a:solidFill>
-              </a:defRPr>
-            </a:pPr>
-          </a:p>
-          <a:p>
-            <a:pPr>
-              <a:spcAft>
-                <a:spcPts val="1200"/>
+                <a:spcPts val="1000"/>
+              </a:spcAft>
+              <a:defRPr sz="1800">
+                <a:solidFill>
+                  <a:srgbClr val="323232"/>
+                </a:solidFill>
+              </a:defRPr>
+            </a:pPr>
+          </a:p>
+          <a:p>
+            <a:pPr>
+              <a:spcAft>
+                <a:spcPts val="1000"/>
               </a:spcAft>
               <a:defRPr sz="1800">
                 <a:solidFill>
@@ -4673,7 +4433,7 @@
           <a:p>
             <a:pPr>
               <a:spcAft>
-                <a:spcPts val="1200"/>
+                <a:spcPts val="1000"/>
               </a:spcAft>
               <a:defRPr sz="1800">
                 <a:solidFill>
@@ -4695,7 +4455,7 @@
 </p:sld>
 </file>
 
-<file path=ppt/slides/slide3.xml><?xml version="1.0" encoding="utf-8"?>
+<file path=ppt/slides/slide4.xml><?xml version="1.0" encoding="utf-8"?>
 <p:sld xmlns:a="http://schemas.openxmlformats.org/drawingml/2006/main" xmlns:p="http://schemas.openxmlformats.org/presentationml/2006/main" xmlns:r="http://schemas.openxmlformats.org/officeDocument/2006/relationships">
   <p:cSld>
     <p:spTree>
@@ -4714,7 +4474,7 @@
         <p:spPr>
           <a:xfrm>
             <a:off x="0" y="0"/>
-            <a:ext cx="12191695" cy="1097280"/>
+            <a:ext cx="12191695" cy="914400"/>
           </a:xfrm>
           <a:prstGeom prst="rect">
             <a:avLst/>
@@ -4756,8 +4516,8 @@
         </p:nvSpPr>
         <p:spPr>
           <a:xfrm>
-            <a:off x="457200" y="274320"/>
-            <a:ext cx="10972800" cy="731520"/>
+            <a:off x="457200" y="228600"/>
+            <a:ext cx="10972800" cy="548640"/>
           </a:xfrm>
           <a:prstGeom prst="rect">
             <a:avLst/>
@@ -4771,7 +4531,7 @@
           <a:lstStyle/>
           <a:p>
             <a:pPr>
-              <a:defRPr sz="3200" b="1">
+              <a:defRPr sz="2800" b="1">
                 <a:solidFill>
                   <a:srgbClr val="FFFFFF"/>
                 </a:solidFill>
@@ -4791,8 +4551,8 @@
         </p:nvSpPr>
         <p:spPr>
           <a:xfrm>
-            <a:off x="457200" y="1371600"/>
-            <a:ext cx="5029200" cy="5029200"/>
+            <a:off x="457200" y="1188720"/>
+            <a:ext cx="5029200" cy="5303520"/>
           </a:xfrm>
           <a:prstGeom prst="rect">
             <a:avLst/>
@@ -4807,7 +4567,7 @@
           <a:p>
             <a:pPr>
               <a:spcAft>
-                <a:spcPts val="1200"/>
+                <a:spcPts val="1000"/>
               </a:spcAft>
               <a:defRPr sz="1800">
                 <a:solidFill>
@@ -4822,7 +4582,7 @@
           <a:p>
             <a:pPr>
               <a:spcAft>
-                <a:spcPts val="1200"/>
+                <a:spcPts val="1000"/>
               </a:spcAft>
               <a:defRPr sz="1800">
                 <a:solidFill>
@@ -4837,19 +4597,19 @@
           <a:p>
             <a:pPr>
               <a:spcAft>
-                <a:spcPts val="1200"/>
-              </a:spcAft>
-              <a:defRPr sz="1800">
-                <a:solidFill>
-                  <a:srgbClr val="323232"/>
-                </a:solidFill>
-              </a:defRPr>
-            </a:pPr>
-          </a:p>
-          <a:p>
-            <a:pPr>
-              <a:spcAft>
-                <a:spcPts val="1200"/>
+                <a:spcPts val="1000"/>
+              </a:spcAft>
+              <a:defRPr sz="1800">
+                <a:solidFill>
+                  <a:srgbClr val="323232"/>
+                </a:solidFill>
+              </a:defRPr>
+            </a:pPr>
+          </a:p>
+          <a:p>
+            <a:pPr>
+              <a:spcAft>
+                <a:spcPts val="1000"/>
               </a:spcAft>
               <a:defRPr sz="1800">
                 <a:solidFill>
@@ -4864,7 +4624,7 @@
           <a:p>
             <a:pPr>
               <a:spcAft>
-                <a:spcPts val="1200"/>
+                <a:spcPts val="1000"/>
               </a:spcAft>
               <a:defRPr sz="1800">
                 <a:solidFill>
@@ -4879,19 +4639,19 @@
           <a:p>
             <a:pPr>
               <a:spcAft>
-                <a:spcPts val="1200"/>
-              </a:spcAft>
-              <a:defRPr sz="1800">
-                <a:solidFill>
-                  <a:srgbClr val="323232"/>
-                </a:solidFill>
-              </a:defRPr>
-            </a:pPr>
-          </a:p>
-          <a:p>
-            <a:pPr>
-              <a:spcAft>
-                <a:spcPts val="1200"/>
+                <a:spcPts val="1000"/>
+              </a:spcAft>
+              <a:defRPr sz="1800">
+                <a:solidFill>
+                  <a:srgbClr val="323232"/>
+                </a:solidFill>
+              </a:defRPr>
+            </a:pPr>
+          </a:p>
+          <a:p>
+            <a:pPr>
+              <a:spcAft>
+                <a:spcPts val="1000"/>
               </a:spcAft>
               <a:defRPr sz="1800">
                 <a:solidFill>
@@ -4906,7 +4666,7 @@
           <a:p>
             <a:pPr>
               <a:spcAft>
-                <a:spcPts val="1200"/>
+                <a:spcPts val="1000"/>
               </a:spcAft>
               <a:defRPr sz="1800">
                 <a:solidFill>
@@ -4921,85 +4681,28 @@
           <a:p>
             <a:pPr>
               <a:spcAft>
-                <a:spcPts val="1200"/>
-              </a:spcAft>
-              <a:defRPr sz="1800">
-                <a:solidFill>
-                  <a:srgbClr val="323232"/>
-                </a:solidFill>
-              </a:defRPr>
-            </a:pPr>
-          </a:p>
-          <a:p>
-            <a:pPr>
-              <a:spcAft>
-                <a:spcPts val="1200"/>
-              </a:spcAft>
-              <a:defRPr sz="1800">
-                <a:solidFill>
-                  <a:srgbClr val="323232"/>
-                </a:solidFill>
-              </a:defRPr>
-            </a:pPr>
-            <a:r>
-              <a:t>4. Select Facility:</a:t>
-            </a:r>
-          </a:p>
-          <a:p>
-            <a:pPr>
-              <a:spcAft>
-                <a:spcPts val="1200"/>
-              </a:spcAft>
-              <a:defRPr sz="1800">
-                <a:solidFill>
-                  <a:srgbClr val="323232"/>
-                </a:solidFill>
-              </a:defRPr>
-            </a:pPr>
-            <a:r>
-              <a:t>   PENANG, FAB10B, etc.</a:t>
-            </a:r>
-          </a:p>
-          <a:p>
-            <a:pPr>
-              <a:spcAft>
-                <a:spcPts val="1200"/>
-              </a:spcAft>
-              <a:defRPr sz="1800">
-                <a:solidFill>
-                  <a:srgbClr val="323232"/>
-                </a:solidFill>
-              </a:defRPr>
-            </a:pPr>
-          </a:p>
-          <a:p>
-            <a:pPr>
-              <a:spcAft>
-                <a:spcPts val="1200"/>
-              </a:spcAft>
-              <a:defRPr sz="1800">
-                <a:solidFill>
-                  <a:srgbClr val="323232"/>
-                </a:solidFill>
-              </a:defRPr>
-            </a:pPr>
-            <a:r>
-              <a:t>5. Set Work Week Range:</a:t>
-            </a:r>
-          </a:p>
-          <a:p>
-            <a:pPr>
-              <a:spcAft>
-                <a:spcPts val="1200"/>
-              </a:spcAft>
-              <a:defRPr sz="1800">
-                <a:solidFill>
-                  <a:srgbClr val="323232"/>
-                </a:solidFill>
-              </a:defRPr>
-            </a:pPr>
-            <a:r>
-              <a:t>   Year + Start/End weeks</a:t>
+                <a:spcPts val="1000"/>
+              </a:spcAft>
+              <a:defRPr sz="1800">
+                <a:solidFill>
+                  <a:srgbClr val="323232"/>
+                </a:solidFill>
+              </a:defRPr>
+            </a:pPr>
+          </a:p>
+          <a:p>
+            <a:pPr>
+              <a:spcAft>
+                <a:spcPts val="1000"/>
+              </a:spcAft>
+              <a:defRPr sz="1800">
+                <a:solidFill>
+                  <a:srgbClr val="323232"/>
+                </a:solidFill>
+              </a:defRPr>
+            </a:pPr>
+            <a:r>
+              <a:t>4. Select Facility and Work Weeks</a:t>
             </a:r>
           </a:p>
         </p:txBody>
@@ -5012,18 +4715,18 @@
         </p:nvSpPr>
         <p:spPr>
           <a:xfrm>
-            <a:off x="5943600" y="1371600"/>
-            <a:ext cx="5760720" cy="5029200"/>
+            <a:off x="5943600" y="1188720"/>
+            <a:ext cx="5760720" cy="5303520"/>
           </a:xfrm>
           <a:prstGeom prst="roundRect">
             <a:avLst/>
           </a:prstGeom>
           <a:solidFill>
-            <a:srgbClr val="F0F0F0"/>
+            <a:srgbClr val="F5F5F5"/>
           </a:solidFill>
           <a:ln>
             <a:solidFill>
-              <a:srgbClr val="969696"/>
+              <a:srgbClr val="B4B4B4"/>
             </a:solidFill>
           </a:ln>
         </p:spPr>
@@ -5057,8 +4760,8 @@
         </p:nvSpPr>
         <p:spPr>
           <a:xfrm>
-            <a:off x="6126480" y="1554480"/>
-            <a:ext cx="5394960" cy="4663440"/>
+            <a:off x="6126480" y="1371600"/>
+            <a:ext cx="5394960" cy="4937760"/>
           </a:xfrm>
           <a:prstGeom prst="rect">
             <a:avLst/>
@@ -5177,7 +4880,7 @@
 </p:sld>
 </file>
 
-<file path=ppt/slides/slide4.xml><?xml version="1.0" encoding="utf-8"?>
+<file path=ppt/slides/slide5.xml><?xml version="1.0" encoding="utf-8"?>
 <p:sld xmlns:a="http://schemas.openxmlformats.org/drawingml/2006/main" xmlns:p="http://schemas.openxmlformats.org/presentationml/2006/main" xmlns:r="http://schemas.openxmlformats.org/officeDocument/2006/relationships">
   <p:cSld>
     <p:spTree>
@@ -5196,7 +4899,7 @@
         <p:spPr>
           <a:xfrm>
             <a:off x="0" y="0"/>
-            <a:ext cx="12191695" cy="1097280"/>
+            <a:ext cx="12191695" cy="914400"/>
           </a:xfrm>
           <a:prstGeom prst="rect">
             <a:avLst/>
@@ -5238,8 +4941,8 @@
         </p:nvSpPr>
         <p:spPr>
           <a:xfrm>
-            <a:off x="457200" y="274320"/>
-            <a:ext cx="10972800" cy="731520"/>
+            <a:off x="457200" y="228600"/>
+            <a:ext cx="10972800" cy="548640"/>
           </a:xfrm>
           <a:prstGeom prst="rect">
             <a:avLst/>
@@ -5253,7 +4956,7 @@
           <a:lstStyle/>
           <a:p>
             <a:pPr>
-              <a:defRPr sz="3200" b="1">
+              <a:defRPr sz="2800" b="1">
                 <a:solidFill>
                   <a:srgbClr val="FFFFFF"/>
                 </a:solidFill>
@@ -5273,8 +4976,8 @@
         </p:nvSpPr>
         <p:spPr>
           <a:xfrm>
-            <a:off x="457200" y="1371600"/>
-            <a:ext cx="5029200" cy="5029200"/>
+            <a:off x="457200" y="1188720"/>
+            <a:ext cx="5029200" cy="5303520"/>
           </a:xfrm>
           <a:prstGeom prst="rect">
             <a:avLst/>
@@ -5289,7 +4992,7 @@
           <a:p>
             <a:pPr>
               <a:spcAft>
-                <a:spcPts val="1200"/>
+                <a:spcPts val="1000"/>
               </a:spcAft>
               <a:defRPr sz="1800">
                 <a:solidFill>
@@ -5304,19 +5007,19 @@
           <a:p>
             <a:pPr>
               <a:spcAft>
-                <a:spcPts val="1200"/>
-              </a:spcAft>
-              <a:defRPr sz="1800">
-                <a:solidFill>
-                  <a:srgbClr val="323232"/>
-                </a:solidFill>
-              </a:defRPr>
-            </a:pPr>
-          </a:p>
-          <a:p>
-            <a:pPr>
-              <a:spcAft>
-                <a:spcPts val="1200"/>
+                <a:spcPts val="1000"/>
+              </a:spcAft>
+              <a:defRPr sz="1800">
+                <a:solidFill>
+                  <a:srgbClr val="323232"/>
+                </a:solidFill>
+              </a:defRPr>
+            </a:pPr>
+          </a:p>
+          <a:p>
+            <a:pPr>
+              <a:spcAft>
+                <a:spcPts val="1000"/>
               </a:spcAft>
               <a:defRPr sz="1800">
                 <a:solidFill>
@@ -5331,19 +5034,19 @@
           <a:p>
             <a:pPr>
               <a:spcAft>
-                <a:spcPts val="1200"/>
-              </a:spcAft>
-              <a:defRPr sz="1800">
-                <a:solidFill>
-                  <a:srgbClr val="323232"/>
-                </a:solidFill>
-              </a:defRPr>
-            </a:pPr>
-          </a:p>
-          <a:p>
-            <a:pPr>
-              <a:spcAft>
-                <a:spcPts val="1200"/>
+                <a:spcPts val="1000"/>
+              </a:spcAft>
+              <a:defRPr sz="1800">
+                <a:solidFill>
+                  <a:srgbClr val="323232"/>
+                </a:solidFill>
+              </a:defRPr>
+            </a:pPr>
+          </a:p>
+          <a:p>
+            <a:pPr>
+              <a:spcAft>
+                <a:spcPts val="1000"/>
               </a:spcAft>
               <a:defRPr sz="1800">
                 <a:solidFill>
@@ -5358,19 +5061,19 @@
           <a:p>
             <a:pPr>
               <a:spcAft>
-                <a:spcPts val="1200"/>
-              </a:spcAft>
-              <a:defRPr sz="1800">
-                <a:solidFill>
-                  <a:srgbClr val="323232"/>
-                </a:solidFill>
-              </a:defRPr>
-            </a:pPr>
-          </a:p>
-          <a:p>
-            <a:pPr>
-              <a:spcAft>
-                <a:spcPts val="1200"/>
+                <a:spcPts val="1000"/>
+              </a:spcAft>
+              <a:defRPr sz="1800">
+                <a:solidFill>
+                  <a:srgbClr val="323232"/>
+                </a:solidFill>
+              </a:defRPr>
+            </a:pPr>
+          </a:p>
+          <a:p>
+            <a:pPr>
+              <a:spcAft>
+                <a:spcPts val="1000"/>
               </a:spcAft>
               <a:defRPr sz="1800">
                 <a:solidFill>
@@ -5385,19 +5088,19 @@
           <a:p>
             <a:pPr>
               <a:spcAft>
-                <a:spcPts val="1200"/>
-              </a:spcAft>
-              <a:defRPr sz="1800">
-                <a:solidFill>
-                  <a:srgbClr val="323232"/>
-                </a:solidFill>
-              </a:defRPr>
-            </a:pPr>
-          </a:p>
-          <a:p>
-            <a:pPr>
-              <a:spcAft>
-                <a:spcPts val="1200"/>
+                <a:spcPts val="1000"/>
+              </a:spcAft>
+              <a:defRPr sz="1800">
+                <a:solidFill>
+                  <a:srgbClr val="323232"/>
+                </a:solidFill>
+              </a:defRPr>
+            </a:pPr>
+          </a:p>
+          <a:p>
+            <a:pPr>
+              <a:spcAft>
+                <a:spcPts val="1000"/>
               </a:spcAft>
               <a:defRPr sz="1800">
                 <a:solidFill>
@@ -5412,7 +5115,7 @@
           <a:p>
             <a:pPr>
               <a:spcAft>
-                <a:spcPts val="1200"/>
+                <a:spcPts val="1000"/>
               </a:spcAft>
               <a:defRPr sz="1800">
                 <a:solidFill>
@@ -5434,18 +5137,18 @@
         </p:nvSpPr>
         <p:spPr>
           <a:xfrm>
-            <a:off x="5943600" y="1371600"/>
-            <a:ext cx="5760720" cy="5029200"/>
+            <a:off x="5943600" y="1188720"/>
+            <a:ext cx="5760720" cy="5303520"/>
           </a:xfrm>
           <a:prstGeom prst="roundRect">
             <a:avLst/>
           </a:prstGeom>
           <a:solidFill>
-            <a:srgbClr val="F0F0F0"/>
+            <a:srgbClr val="F5F5F5"/>
           </a:solidFill>
           <a:ln>
             <a:solidFill>
-              <a:srgbClr val="969696"/>
+              <a:srgbClr val="B4B4B4"/>
             </a:solidFill>
           </a:ln>
         </p:spPr>
@@ -5479,8 +5182,8 @@
         </p:nvSpPr>
         <p:spPr>
           <a:xfrm>
-            <a:off x="6126480" y="1554480"/>
-            <a:ext cx="5394960" cy="4663440"/>
+            <a:off x="6126480" y="1371600"/>
+            <a:ext cx="5394960" cy="4937760"/>
           </a:xfrm>
           <a:prstGeom prst="rect">
             <a:avLst/>
@@ -5571,7 +5274,7 @@
 </p:sld>
 </file>
 
-<file path=ppt/slides/slide5.xml><?xml version="1.0" encoding="utf-8"?>
+<file path=ppt/slides/slide6.xml><?xml version="1.0" encoding="utf-8"?>
 <p:sld xmlns:a="http://schemas.openxmlformats.org/drawingml/2006/main" xmlns:p="http://schemas.openxmlformats.org/presentationml/2006/main" xmlns:r="http://schemas.openxmlformats.org/officeDocument/2006/relationships">
   <p:cSld>
     <p:spTree>
@@ -5590,7 +5293,7 @@
         <p:spPr>
           <a:xfrm>
             <a:off x="0" y="0"/>
-            <a:ext cx="12191695" cy="1097280"/>
+            <a:ext cx="12191695" cy="914400"/>
           </a:xfrm>
           <a:prstGeom prst="rect">
             <a:avLst/>
@@ -5632,8 +5335,8 @@
         </p:nvSpPr>
         <p:spPr>
           <a:xfrm>
-            <a:off x="457200" y="274320"/>
-            <a:ext cx="10972800" cy="731520"/>
+            <a:off x="457200" y="228600"/>
+            <a:ext cx="10972800" cy="548640"/>
           </a:xfrm>
           <a:prstGeom prst="rect">
             <a:avLst/>
@@ -5647,7 +5350,7 @@
           <a:lstStyle/>
           <a:p>
             <a:pPr>
-              <a:defRPr sz="3200" b="1">
+              <a:defRPr sz="2800" b="1">
                 <a:solidFill>
                   <a:srgbClr val="FFFFFF"/>
                 </a:solidFill>
@@ -5667,8 +5370,8 @@
         </p:nvSpPr>
         <p:spPr>
           <a:xfrm>
-            <a:off x="457200" y="1371600"/>
-            <a:ext cx="5029200" cy="5029200"/>
+            <a:off x="457200" y="1188720"/>
+            <a:ext cx="5029200" cy="5303520"/>
           </a:xfrm>
           <a:prstGeom prst="rect">
             <a:avLst/>
@@ -5683,7 +5386,7 @@
           <a:p>
             <a:pPr>
               <a:spcAft>
-                <a:spcPts val="1200"/>
+                <a:spcPts val="1000"/>
               </a:spcAft>
               <a:defRPr sz="1800">
                 <a:solidFill>
@@ -5698,7 +5401,7 @@
           <a:p>
             <a:pPr>
               <a:spcAft>
-                <a:spcPts val="1200"/>
+                <a:spcPts val="1000"/>
               </a:spcAft>
               <a:defRPr sz="1800">
                 <a:solidFill>
@@ -5713,19 +5416,19 @@
           <a:p>
             <a:pPr>
               <a:spcAft>
-                <a:spcPts val="1200"/>
-              </a:spcAft>
-              <a:defRPr sz="1800">
-                <a:solidFill>
-                  <a:srgbClr val="323232"/>
-                </a:solidFill>
-              </a:defRPr>
-            </a:pPr>
-          </a:p>
-          <a:p>
-            <a:pPr>
-              <a:spcAft>
-                <a:spcPts val="1200"/>
+                <a:spcPts val="1000"/>
+              </a:spcAft>
+              <a:defRPr sz="1800">
+                <a:solidFill>
+                  <a:srgbClr val="323232"/>
+                </a:solidFill>
+              </a:defRPr>
+            </a:pPr>
+          </a:p>
+          <a:p>
+            <a:pPr>
+              <a:spcAft>
+                <a:spcPts val="1000"/>
               </a:spcAft>
               <a:defRPr sz="1800">
                 <a:solidFill>
@@ -5740,49 +5443,49 @@
           <a:p>
             <a:pPr>
               <a:spcAft>
-                <a:spcPts val="1200"/>
-              </a:spcAft>
-              <a:defRPr sz="1800">
-                <a:solidFill>
-                  <a:srgbClr val="323232"/>
-                </a:solidFill>
-              </a:defRPr>
-            </a:pPr>
-          </a:p>
-          <a:p>
-            <a:pPr>
-              <a:spcAft>
-                <a:spcPts val="1200"/>
-              </a:spcAft>
-              <a:defRPr sz="1800">
-                <a:solidFill>
-                  <a:srgbClr val="323232"/>
-                </a:solidFill>
-              </a:defRPr>
-            </a:pPr>
-            <a:r>
-              <a:t>💡 TIP: For target lines, select</a:t>
-            </a:r>
-          </a:p>
-          <a:p>
-            <a:pPr>
-              <a:spcAft>
-                <a:spcPts val="1200"/>
-              </a:spcAft>
-              <a:defRPr sz="1800">
-                <a:solidFill>
-                  <a:srgbClr val="323232"/>
-                </a:solidFill>
-              </a:defRPr>
-            </a:pPr>
-            <a:r>
-              <a:t>   series with SAME:</a:t>
-            </a:r>
-          </a:p>
-          <a:p>
-            <a:pPr>
-              <a:spcAft>
-                <a:spcPts val="1200"/>
+                <a:spcPts val="1000"/>
+              </a:spcAft>
+              <a:defRPr sz="1800">
+                <a:solidFill>
+                  <a:srgbClr val="323232"/>
+                </a:solidFill>
+              </a:defRPr>
+            </a:pPr>
+          </a:p>
+          <a:p>
+            <a:pPr>
+              <a:spcAft>
+                <a:spcPts val="1000"/>
+              </a:spcAft>
+              <a:defRPr sz="1800">
+                <a:solidFill>
+                  <a:srgbClr val="323232"/>
+                </a:solidFill>
+              </a:defRPr>
+            </a:pPr>
+            <a:r>
+              <a:t>💡 IMPORTANT for Target Lines:</a:t>
+            </a:r>
+          </a:p>
+          <a:p>
+            <a:pPr>
+              <a:spcAft>
+                <a:spcPts val="1000"/>
+              </a:spcAft>
+              <a:defRPr sz="1800">
+                <a:solidFill>
+                  <a:srgbClr val="323232"/>
+                </a:solidFill>
+              </a:defRPr>
+            </a:pPr>
+            <a:r>
+              <a:t>   Select series with SAME:</a:t>
+            </a:r>
+          </a:p>
+          <a:p>
+            <a:pPr>
+              <a:spcAft>
+                <a:spcPts val="1000"/>
               </a:spcAft>
               <a:defRPr sz="1800">
                 <a:solidFill>
@@ -5797,7 +5500,7 @@
           <a:p>
             <a:pPr>
               <a:spcAft>
-                <a:spcPts val="1200"/>
+                <a:spcPts val="1000"/>
               </a:spcAft>
               <a:defRPr sz="1800">
                 <a:solidFill>
@@ -5812,7 +5515,7 @@
           <a:p>
             <a:pPr>
               <a:spcAft>
-                <a:spcPts val="1200"/>
+                <a:spcPts val="1000"/>
               </a:spcAft>
               <a:defRPr sz="1800">
                 <a:solidFill>
@@ -5834,18 +5537,18 @@
         </p:nvSpPr>
         <p:spPr>
           <a:xfrm>
-            <a:off x="5943600" y="1371600"/>
-            <a:ext cx="5760720" cy="5029200"/>
+            <a:off x="5943600" y="1188720"/>
+            <a:ext cx="5760720" cy="5303520"/>
           </a:xfrm>
           <a:prstGeom prst="roundRect">
             <a:avLst/>
           </a:prstGeom>
           <a:solidFill>
-            <a:srgbClr val="F0F0F0"/>
+            <a:srgbClr val="F5F5F5"/>
           </a:solidFill>
           <a:ln>
             <a:solidFill>
-              <a:srgbClr val="969696"/>
+              <a:srgbClr val="B4B4B4"/>
             </a:solidFill>
           </a:ln>
         </p:spPr>
@@ -5879,8 +5582,8 @@
         </p:nvSpPr>
         <p:spPr>
           <a:xfrm>
-            <a:off x="6126480" y="1554480"/>
-            <a:ext cx="5394960" cy="4663440"/>
+            <a:off x="6126480" y="1371600"/>
+            <a:ext cx="5394960" cy="4937760"/>
           </a:xfrm>
           <a:prstGeom prst="rect">
             <a:avLst/>
@@ -5950,15 +5653,11 @@
             </a:r>
             <a:br/>
             <a:r>
-              <a:t>│  ☐ Y62P_SOCAMM2_64GB_8533MTPS_HMFN             │</a:t>
-            </a:r>
-            <a:br/>
-            <a:r>
-              <a:t>│  ☐ Y62P_SOCAMM2_64GB_8533MTPS_SLT              │</a:t>
-            </a:r>
-            <a:br/>
-            <a:r>
-              <a:t>│  ☐ Y62P_SOCAMM2_64GB_8533MTPS_ELC              │</a:t>
+              <a:t>│  💡 TIP: For targets, select series            │</a:t>
+            </a:r>
+            <a:br/>
+            <a:r>
+              <a:t>│     with SAME DID + Density + Speed            │</a:t>
             </a:r>
             <a:br/>
             <a:r>
@@ -5983,7 +5682,7 @@
 </p:sld>
 </file>
 
-<file path=ppt/slides/slide6.xml><?xml version="1.0" encoding="utf-8"?>
+<file path=ppt/slides/slide7.xml><?xml version="1.0" encoding="utf-8"?>
 <p:sld xmlns:a="http://schemas.openxmlformats.org/drawingml/2006/main" xmlns:p="http://schemas.openxmlformats.org/presentationml/2006/main" xmlns:r="http://schemas.openxmlformats.org/officeDocument/2006/relationships">
   <p:cSld>
     <p:spTree>
@@ -6002,7 +5701,7 @@
         <p:spPr>
           <a:xfrm>
             <a:off x="0" y="0"/>
-            <a:ext cx="12191695" cy="1097280"/>
+            <a:ext cx="12191695" cy="914400"/>
           </a:xfrm>
           <a:prstGeom prst="rect">
             <a:avLst/>
@@ -6044,8 +5743,8 @@
         </p:nvSpPr>
         <p:spPr>
           <a:xfrm>
-            <a:off x="457200" y="274320"/>
-            <a:ext cx="10972800" cy="731520"/>
+            <a:off x="457200" y="228600"/>
+            <a:ext cx="10972800" cy="548640"/>
           </a:xfrm>
           <a:prstGeom prst="rect">
             <a:avLst/>
@@ -6059,7 +5758,7 @@
           <a:lstStyle/>
           <a:p>
             <a:pPr>
-              <a:defRPr sz="3200" b="1">
+              <a:defRPr sz="2800" b="1">
                 <a:solidFill>
                   <a:srgbClr val="FFFFFF"/>
                 </a:solidFill>
@@ -6079,8 +5778,8 @@
         </p:nvSpPr>
         <p:spPr>
           <a:xfrm>
-            <a:off x="457200" y="1371600"/>
-            <a:ext cx="5029200" cy="5029200"/>
+            <a:off x="457200" y="1188720"/>
+            <a:ext cx="5029200" cy="5303520"/>
           </a:xfrm>
           <a:prstGeom prst="rect">
             <a:avLst/>
@@ -6095,7 +5794,7 @@
           <a:p>
             <a:pPr>
               <a:spcAft>
-                <a:spcPts val="1200"/>
+                <a:spcPts val="1000"/>
               </a:spcAft>
               <a:defRPr sz="1800">
                 <a:solidFill>
@@ -6110,19 +5809,19 @@
           <a:p>
             <a:pPr>
               <a:spcAft>
-                <a:spcPts val="1200"/>
-              </a:spcAft>
-              <a:defRPr sz="1800">
-                <a:solidFill>
-                  <a:srgbClr val="323232"/>
-                </a:solidFill>
-              </a:defRPr>
-            </a:pPr>
-          </a:p>
-          <a:p>
-            <a:pPr>
-              <a:spcAft>
-                <a:spcPts val="1200"/>
+                <a:spcPts val="1000"/>
+              </a:spcAft>
+              <a:defRPr sz="1800">
+                <a:solidFill>
+                  <a:srgbClr val="323232"/>
+                </a:solidFill>
+              </a:defRPr>
+            </a:pPr>
+          </a:p>
+          <a:p>
+            <a:pPr>
+              <a:spcAft>
+                <a:spcPts val="1000"/>
               </a:spcAft>
               <a:defRPr sz="1800">
                 <a:solidFill>
@@ -6137,7 +5836,7 @@
           <a:p>
             <a:pPr>
               <a:spcAft>
-                <a:spcPts val="1200"/>
+                <a:spcPts val="1000"/>
               </a:spcAft>
               <a:defRPr sz="1800">
                 <a:solidFill>
@@ -6152,19 +5851,19 @@
           <a:p>
             <a:pPr>
               <a:spcAft>
-                <a:spcPts val="1200"/>
-              </a:spcAft>
-              <a:defRPr sz="1800">
-                <a:solidFill>
-                  <a:srgbClr val="323232"/>
-                </a:solidFill>
-              </a:defRPr>
-            </a:pPr>
-          </a:p>
-          <a:p>
-            <a:pPr>
-              <a:spcAft>
-                <a:spcPts val="1200"/>
+                <a:spcPts val="1000"/>
+              </a:spcAft>
+              <a:defRPr sz="1800">
+                <a:solidFill>
+                  <a:srgbClr val="323232"/>
+                </a:solidFill>
+              </a:defRPr>
+            </a:pPr>
+          </a:p>
+          <a:p>
+            <a:pPr>
+              <a:spcAft>
+                <a:spcPts val="1000"/>
               </a:spcAft>
               <a:defRPr sz="1800">
                 <a:solidFill>
@@ -6179,19 +5878,19 @@
           <a:p>
             <a:pPr>
               <a:spcAft>
-                <a:spcPts val="1200"/>
-              </a:spcAft>
-              <a:defRPr sz="1800">
-                <a:solidFill>
-                  <a:srgbClr val="323232"/>
-                </a:solidFill>
-              </a:defRPr>
-            </a:pPr>
-          </a:p>
-          <a:p>
-            <a:pPr>
-              <a:spcAft>
-                <a:spcPts val="1200"/>
+                <a:spcPts val="1000"/>
+              </a:spcAft>
+              <a:defRPr sz="1800">
+                <a:solidFill>
+                  <a:srgbClr val="323232"/>
+                </a:solidFill>
+              </a:defRPr>
+            </a:pPr>
+          </a:p>
+          <a:p>
+            <a:pPr>
+              <a:spcAft>
+                <a:spcPts val="1000"/>
               </a:spcAft>
               <a:defRPr sz="1800">
                 <a:solidFill>
@@ -6206,7 +5905,7 @@
           <a:p>
             <a:pPr>
               <a:spcAft>
-                <a:spcPts val="1200"/>
+                <a:spcPts val="1000"/>
               </a:spcAft>
               <a:defRPr sz="1800">
                 <a:solidFill>
@@ -6221,7 +5920,7 @@
           <a:p>
             <a:pPr>
               <a:spcAft>
-                <a:spcPts val="1200"/>
+                <a:spcPts val="1000"/>
               </a:spcAft>
               <a:defRPr sz="1800">
                 <a:solidFill>
@@ -6236,7 +5935,7 @@
           <a:p>
             <a:pPr>
               <a:spcAft>
-                <a:spcPts val="1200"/>
+                <a:spcPts val="1000"/>
               </a:spcAft>
               <a:defRPr sz="1800">
                 <a:solidFill>
@@ -6246,48 +5945,6 @@
             </a:pPr>
             <a:r>
               <a:t>   • Green dotted = ELC target</a:t>
-            </a:r>
-          </a:p>
-          <a:p>
-            <a:pPr>
-              <a:spcAft>
-                <a:spcPts val="1200"/>
-              </a:spcAft>
-              <a:defRPr sz="1800">
-                <a:solidFill>
-                  <a:srgbClr val="323232"/>
-                </a:solidFill>
-              </a:defRPr>
-            </a:pPr>
-          </a:p>
-          <a:p>
-            <a:pPr>
-              <a:spcAft>
-                <a:spcPts val="1200"/>
-              </a:spcAft>
-              <a:defRPr sz="1800">
-                <a:solidFill>
-                  <a:srgbClr val="323232"/>
-                </a:solidFill>
-              </a:defRPr>
-            </a:pPr>
-            <a:r>
-              <a:t>⚠️ If checkbox doesn't work:</a:t>
-            </a:r>
-          </a:p>
-          <a:p>
-            <a:pPr>
-              <a:spcAft>
-                <a:spcPts val="1200"/>
-              </a:spcAft>
-              <a:defRPr sz="1800">
-                <a:solidFill>
-                  <a:srgbClr val="323232"/>
-                </a:solidFill>
-              </a:defRPr>
-            </a:pPr>
-            <a:r>
-              <a:t>   Select single config (same DID+Density+Speed)</a:t>
             </a:r>
           </a:p>
         </p:txBody>
@@ -6300,18 +5957,18 @@
         </p:nvSpPr>
         <p:spPr>
           <a:xfrm>
-            <a:off x="5943600" y="1371600"/>
-            <a:ext cx="5760720" cy="5029200"/>
+            <a:off x="5943600" y="1188720"/>
+            <a:ext cx="5760720" cy="5303520"/>
           </a:xfrm>
           <a:prstGeom prst="roundRect">
             <a:avLst/>
           </a:prstGeom>
           <a:solidFill>
-            <a:srgbClr val="F0F0F0"/>
+            <a:srgbClr val="F5F5F5"/>
           </a:solidFill>
           <a:ln>
             <a:solidFill>
-              <a:srgbClr val="969696"/>
+              <a:srgbClr val="B4B4B4"/>
             </a:solidFill>
           </a:ln>
         </p:spPr>
@@ -6345,8 +6002,8 @@
         </p:nvSpPr>
         <p:spPr>
           <a:xfrm>
-            <a:off x="6126480" y="1554480"/>
-            <a:ext cx="5394960" cy="4663440"/>
+            <a:off x="6126480" y="1371600"/>
+            <a:ext cx="5394960" cy="4937760"/>
           </a:xfrm>
           <a:prstGeom prst="rect">
             <a:avLst/>
@@ -6428,19 +6085,7 @@
             </a:r>
             <a:br/>
             <a:r>
-              <a:t>│  series share the SAME:                         │</a:t>
-            </a:r>
-            <a:br/>
-            <a:r>
-              <a:t>│  • Design ID                                    │</a:t>
-            </a:r>
-            <a:br/>
-            <a:r>
-              <a:t>│  • Density                                      │</a:t>
-            </a:r>
-            <a:br/>
-            <a:r>
-              <a:t>│  • Speed                                        │</a:t>
+              <a:t>│  series share SAME DID + Density + Speed        │</a:t>
             </a:r>
             <a:br/>
             <a:r>
@@ -6457,7 +6102,7 @@
 </p:sld>
 </file>
 
-<file path=ppt/slides/slide7.xml><?xml version="1.0" encoding="utf-8"?>
+<file path=ppt/slides/slide8.xml><?xml version="1.0" encoding="utf-8"?>
 <p:sld xmlns:a="http://schemas.openxmlformats.org/drawingml/2006/main" xmlns:p="http://schemas.openxmlformats.org/presentationml/2006/main" xmlns:r="http://schemas.openxmlformats.org/officeDocument/2006/relationships">
   <p:cSld>
     <p:spTree>
@@ -6476,7 +6121,7 @@
         <p:spPr>
           <a:xfrm>
             <a:off x="0" y="0"/>
-            <a:ext cx="12191695" cy="1097280"/>
+            <a:ext cx="12191695" cy="914400"/>
           </a:xfrm>
           <a:prstGeom prst="rect">
             <a:avLst/>
@@ -6518,8 +6163,8 @@
         </p:nvSpPr>
         <p:spPr>
           <a:xfrm>
-            <a:off x="457200" y="274320"/>
-            <a:ext cx="10972800" cy="731520"/>
+            <a:off x="457200" y="228600"/>
+            <a:ext cx="10972800" cy="548640"/>
           </a:xfrm>
           <a:prstGeom prst="rect">
             <a:avLst/>
@@ -6533,7 +6178,7 @@
           <a:lstStyle/>
           <a:p>
             <a:pPr>
-              <a:defRPr sz="3200" b="1">
+              <a:defRPr sz="2800" b="1">
                 <a:solidFill>
                   <a:srgbClr val="FFFFFF"/>
                 </a:solidFill>
@@ -6553,8 +6198,8 @@
         </p:nvSpPr>
         <p:spPr>
           <a:xfrm>
-            <a:off x="457200" y="1371600"/>
-            <a:ext cx="5029200" cy="5029200"/>
+            <a:off x="457200" y="1188720"/>
+            <a:ext cx="5029200" cy="5303520"/>
           </a:xfrm>
           <a:prstGeom prst="rect">
             <a:avLst/>
@@ -6569,7 +6214,7 @@
           <a:p>
             <a:pPr>
               <a:spcAft>
-                <a:spcPts val="1200"/>
+                <a:spcPts val="1000"/>
               </a:spcAft>
               <a:defRPr sz="1800">
                 <a:solidFill>
@@ -6584,19 +6229,19 @@
           <a:p>
             <a:pPr>
               <a:spcAft>
-                <a:spcPts val="1200"/>
-              </a:spcAft>
-              <a:defRPr sz="1800">
-                <a:solidFill>
-                  <a:srgbClr val="323232"/>
-                </a:solidFill>
-              </a:defRPr>
-            </a:pPr>
-          </a:p>
-          <a:p>
-            <a:pPr>
-              <a:spcAft>
-                <a:spcPts val="1200"/>
+                <a:spcPts val="1000"/>
+              </a:spcAft>
+              <a:defRPr sz="1800">
+                <a:solidFill>
+                  <a:srgbClr val="323232"/>
+                </a:solidFill>
+              </a:defRPr>
+            </a:pPr>
+          </a:p>
+          <a:p>
+            <a:pPr>
+              <a:spcAft>
+                <a:spcPts val="1000"/>
               </a:spcAft>
               <a:defRPr sz="1800">
                 <a:solidFill>
@@ -6611,7 +6256,7 @@
           <a:p>
             <a:pPr>
               <a:spcAft>
-                <a:spcPts val="1200"/>
+                <a:spcPts val="1000"/>
               </a:spcAft>
               <a:defRPr sz="1800">
                 <a:solidFill>
@@ -6626,19 +6271,19 @@
           <a:p>
             <a:pPr>
               <a:spcAft>
-                <a:spcPts val="1200"/>
-              </a:spcAft>
-              <a:defRPr sz="1800">
-                <a:solidFill>
-                  <a:srgbClr val="323232"/>
-                </a:solidFill>
-              </a:defRPr>
-            </a:pPr>
-          </a:p>
-          <a:p>
-            <a:pPr>
-              <a:spcAft>
-                <a:spcPts val="1200"/>
+                <a:spcPts val="1000"/>
+              </a:spcAft>
+              <a:defRPr sz="1800">
+                <a:solidFill>
+                  <a:srgbClr val="323232"/>
+                </a:solidFill>
+              </a:defRPr>
+            </a:pPr>
+          </a:p>
+          <a:p>
+            <a:pPr>
+              <a:spcAft>
+                <a:spcPts val="1000"/>
               </a:spcAft>
               <a:defRPr sz="1800">
                 <a:solidFill>
@@ -6653,7 +6298,7 @@
           <a:p>
             <a:pPr>
               <a:spcAft>
-                <a:spcPts val="1200"/>
+                <a:spcPts val="1000"/>
               </a:spcAft>
               <a:defRPr sz="1800">
                 <a:solidFill>
@@ -6668,7 +6313,7 @@
           <a:p>
             <a:pPr>
               <a:spcAft>
-                <a:spcPts val="1200"/>
+                <a:spcPts val="1000"/>
               </a:spcAft>
               <a:defRPr sz="1800">
                 <a:solidFill>
@@ -6683,7 +6328,7 @@
           <a:p>
             <a:pPr>
               <a:spcAft>
-                <a:spcPts val="1200"/>
+                <a:spcPts val="1000"/>
               </a:spcAft>
               <a:defRPr sz="1800">
                 <a:solidFill>
@@ -6698,58 +6343,28 @@
           <a:p>
             <a:pPr>
               <a:spcAft>
-                <a:spcPts val="1200"/>
-              </a:spcAft>
-              <a:defRPr sz="1800">
-                <a:solidFill>
-                  <a:srgbClr val="323232"/>
-                </a:solidFill>
-              </a:defRPr>
-            </a:pPr>
-          </a:p>
-          <a:p>
-            <a:pPr>
-              <a:spcAft>
-                <a:spcPts val="1200"/>
-              </a:spcAft>
-              <a:defRPr sz="1800">
-                <a:solidFill>
-                  <a:srgbClr val="323232"/>
-                </a:solidFill>
-              </a:defRPr>
-            </a:pPr>
-            <a:r>
-              <a:t>Compare actual vs target:</a:t>
-            </a:r>
-          </a:p>
-          <a:p>
-            <a:pPr>
-              <a:spcAft>
-                <a:spcPts val="1200"/>
-              </a:spcAft>
-              <a:defRPr sz="1800">
-                <a:solidFill>
-                  <a:srgbClr val="323232"/>
-                </a:solidFill>
-              </a:defRPr>
-            </a:pPr>
-            <a:r>
-              <a:t>• Above target = Good ✓</a:t>
-            </a:r>
-          </a:p>
-          <a:p>
-            <a:pPr>
-              <a:spcAft>
-                <a:spcPts val="1200"/>
-              </a:spcAft>
-              <a:defRPr sz="1800">
-                <a:solidFill>
-                  <a:srgbClr val="323232"/>
-                </a:solidFill>
-              </a:defRPr>
-            </a:pPr>
-            <a:r>
-              <a:t>• Below target = Action needed</a:t>
+                <a:spcPts val="1000"/>
+              </a:spcAft>
+              <a:defRPr sz="1800">
+                <a:solidFill>
+                  <a:srgbClr val="323232"/>
+                </a:solidFill>
+              </a:defRPr>
+            </a:pPr>
+          </a:p>
+          <a:p>
+            <a:pPr>
+              <a:spcAft>
+                <a:spcPts val="1000"/>
+              </a:spcAft>
+              <a:defRPr sz="1800">
+                <a:solidFill>
+                  <a:srgbClr val="323232"/>
+                </a:solidFill>
+              </a:defRPr>
+            </a:pPr>
+            <a:r>
+              <a:t>Compare actual vs target to identify gaps</a:t>
             </a:r>
           </a:p>
         </p:txBody>
@@ -6762,18 +6377,18 @@
         </p:nvSpPr>
         <p:spPr>
           <a:xfrm>
-            <a:off x="5943600" y="1371600"/>
-            <a:ext cx="5760720" cy="5029200"/>
+            <a:off x="5943600" y="1188720"/>
+            <a:ext cx="5760720" cy="5303520"/>
           </a:xfrm>
           <a:prstGeom prst="roundRect">
             <a:avLst/>
           </a:prstGeom>
           <a:solidFill>
-            <a:srgbClr val="F0F0F0"/>
+            <a:srgbClr val="F5F5F5"/>
           </a:solidFill>
           <a:ln>
             <a:solidFill>
-              <a:srgbClr val="969696"/>
+              <a:srgbClr val="B4B4B4"/>
             </a:solidFill>
           </a:ln>
         </p:spPr>
@@ -6807,8 +6422,8 @@
         </p:nvSpPr>
         <p:spPr>
           <a:xfrm>
-            <a:off x="6126480" y="1554480"/>
-            <a:ext cx="5394960" cy="4663440"/>
+            <a:off x="6126480" y="1371600"/>
+            <a:ext cx="5394960" cy="4937760"/>
           </a:xfrm>
           <a:prstGeom prst="rect">
             <a:avLst/>
@@ -6899,7 +6514,7 @@
 </p:sld>
 </file>
 
-<file path=ppt/slides/slide8.xml><?xml version="1.0" encoding="utf-8"?>
+<file path=ppt/slides/slide9.xml><?xml version="1.0" encoding="utf-8"?>
 <p:sld xmlns:a="http://schemas.openxmlformats.org/drawingml/2006/main" xmlns:p="http://schemas.openxmlformats.org/presentationml/2006/main" xmlns:r="http://schemas.openxmlformats.org/officeDocument/2006/relationships">
   <p:cSld>
     <p:spTree>
@@ -6918,7 +6533,7 @@
         <p:spPr>
           <a:xfrm>
             <a:off x="0" y="0"/>
-            <a:ext cx="12191695" cy="1097280"/>
+            <a:ext cx="12191695" cy="914400"/>
           </a:xfrm>
           <a:prstGeom prst="rect">
             <a:avLst/>
@@ -6960,8 +6575,8 @@
         </p:nvSpPr>
         <p:spPr>
           <a:xfrm>
-            <a:off x="457200" y="274320"/>
-            <a:ext cx="10972800" cy="731520"/>
+            <a:off x="457200" y="228600"/>
+            <a:ext cx="10972800" cy="548640"/>
           </a:xfrm>
           <a:prstGeom prst="rect">
             <a:avLst/>
@@ -6975,7 +6590,7 @@
           <a:lstStyle/>
           <a:p>
             <a:pPr>
-              <a:defRPr sz="3200" b="1">
+              <a:defRPr sz="2800" b="1">
                 <a:solidFill>
                   <a:srgbClr val="FFFFFF"/>
                 </a:solidFill>
@@ -6995,8 +6610,8 @@
         </p:nvSpPr>
         <p:spPr>
           <a:xfrm>
-            <a:off x="457200" y="1371600"/>
-            <a:ext cx="5029200" cy="5029200"/>
+            <a:off x="457200" y="1188720"/>
+            <a:ext cx="5029200" cy="5303520"/>
           </a:xfrm>
           <a:prstGeom prst="rect">
             <a:avLst/>
@@ -7011,7 +6626,7 @@
           <a:p>
             <a:pPr>
               <a:spcAft>
-                <a:spcPts val="1200"/>
+                <a:spcPts val="1000"/>
               </a:spcAft>
               <a:defRPr sz="1800">
                 <a:solidFill>
@@ -7026,19 +6641,19 @@
           <a:p>
             <a:pPr>
               <a:spcAft>
-                <a:spcPts val="1200"/>
-              </a:spcAft>
-              <a:defRPr sz="1800">
-                <a:solidFill>
-                  <a:srgbClr val="323232"/>
-                </a:solidFill>
-              </a:defRPr>
-            </a:pPr>
-          </a:p>
-          <a:p>
-            <a:pPr>
-              <a:spcAft>
-                <a:spcPts val="1200"/>
+                <a:spcPts val="1000"/>
+              </a:spcAft>
+              <a:defRPr sz="1800">
+                <a:solidFill>
+                  <a:srgbClr val="323232"/>
+                </a:solidFill>
+              </a:defRPr>
+            </a:pPr>
+          </a:p>
+          <a:p>
+            <a:pPr>
+              <a:spcAft>
+                <a:spcPts val="1000"/>
               </a:spcAft>
               <a:defRPr sz="1800">
                 <a:solidFill>
@@ -7053,19 +6668,19 @@
           <a:p>
             <a:pPr>
               <a:spcAft>
-                <a:spcPts val="1200"/>
-              </a:spcAft>
-              <a:defRPr sz="1800">
-                <a:solidFill>
-                  <a:srgbClr val="323232"/>
-                </a:solidFill>
-              </a:defRPr>
-            </a:pPr>
-          </a:p>
-          <a:p>
-            <a:pPr>
-              <a:spcAft>
-                <a:spcPts val="1200"/>
+                <a:spcPts val="1000"/>
+              </a:spcAft>
+              <a:defRPr sz="1800">
+                <a:solidFill>
+                  <a:srgbClr val="323232"/>
+                </a:solidFill>
+              </a:defRPr>
+            </a:pPr>
+          </a:p>
+          <a:p>
+            <a:pPr>
+              <a:spcAft>
+                <a:spcPts val="1000"/>
               </a:spcAft>
               <a:defRPr sz="1800">
                 <a:solidFill>
@@ -7080,7 +6695,7 @@
           <a:p>
             <a:pPr>
               <a:spcAft>
-                <a:spcPts val="1200"/>
+                <a:spcPts val="1000"/>
               </a:spcAft>
               <a:defRPr sz="1800">
                 <a:solidFill>
@@ -7095,19 +6710,19 @@
           <a:p>
             <a:pPr>
               <a:spcAft>
-                <a:spcPts val="1200"/>
-              </a:spcAft>
-              <a:defRPr sz="1800">
-                <a:solidFill>
-                  <a:srgbClr val="323232"/>
-                </a:solidFill>
-              </a:defRPr>
-            </a:pPr>
-          </a:p>
-          <a:p>
-            <a:pPr>
-              <a:spcAft>
-                <a:spcPts val="1200"/>
+                <a:spcPts val="1000"/>
+              </a:spcAft>
+              <a:defRPr sz="1800">
+                <a:solidFill>
+                  <a:srgbClr val="323232"/>
+                </a:solidFill>
+              </a:defRPr>
+            </a:pPr>
+          </a:p>
+          <a:p>
+            <a:pPr>
+              <a:spcAft>
+                <a:spcPts val="1000"/>
               </a:spcAft>
               <a:defRPr sz="1800">
                 <a:solidFill>
@@ -7122,7 +6737,7 @@
           <a:p>
             <a:pPr>
               <a:spcAft>
-                <a:spcPts val="1200"/>
+                <a:spcPts val="1000"/>
               </a:spcAft>
               <a:defRPr sz="1800">
                 <a:solidFill>
@@ -7137,76 +6752,31 @@
           <a:p>
             <a:pPr>
               <a:spcAft>
-                <a:spcPts val="1200"/>
-              </a:spcAft>
-              <a:defRPr sz="1800">
-                <a:solidFill>
-                  <a:srgbClr val="323232"/>
-                </a:solidFill>
-              </a:defRPr>
-            </a:pPr>
-            <a:r>
-              <a:t>2. Uncheck mismatched series</a:t>
-            </a:r>
-          </a:p>
-          <a:p>
-            <a:pPr>
-              <a:spcAft>
-                <a:spcPts val="1200"/>
-              </a:spcAft>
-              <a:defRPr sz="1800">
-                <a:solidFill>
-                  <a:srgbClr val="323232"/>
-                </a:solidFill>
-              </a:defRPr>
-            </a:pPr>
-            <a:r>
-              <a:t>3. Keep only series with same:</a:t>
-            </a:r>
-          </a:p>
-          <a:p>
-            <a:pPr>
-              <a:spcAft>
-                <a:spcPts val="1200"/>
-              </a:spcAft>
-              <a:defRPr sz="1800">
-                <a:solidFill>
-                  <a:srgbClr val="323232"/>
-                </a:solidFill>
-              </a:defRPr>
-            </a:pPr>
-            <a:r>
-              <a:t>   • Design ID</a:t>
-            </a:r>
-          </a:p>
-          <a:p>
-            <a:pPr>
-              <a:spcAft>
-                <a:spcPts val="1200"/>
-              </a:spcAft>
-              <a:defRPr sz="1800">
-                <a:solidFill>
-                  <a:srgbClr val="323232"/>
-                </a:solidFill>
-              </a:defRPr>
-            </a:pPr>
-            <a:r>
-              <a:t>   • Density</a:t>
-            </a:r>
-          </a:p>
-          <a:p>
-            <a:pPr>
-              <a:spcAft>
-                <a:spcPts val="1200"/>
-              </a:spcAft>
-              <a:defRPr sz="1800">
-                <a:solidFill>
-                  <a:srgbClr val="323232"/>
-                </a:solidFill>
-              </a:defRPr>
-            </a:pPr>
-            <a:r>
-              <a:t>   • Speed</a:t>
+                <a:spcPts val="1000"/>
+              </a:spcAft>
+              <a:defRPr sz="1800">
+                <a:solidFill>
+                  <a:srgbClr val="323232"/>
+                </a:solidFill>
+              </a:defRPr>
+            </a:pPr>
+            <a:r>
+              <a:t>2. Keep only series with same</a:t>
+            </a:r>
+          </a:p>
+          <a:p>
+            <a:pPr>
+              <a:spcAft>
+                <a:spcPts val="1000"/>
+              </a:spcAft>
+              <a:defRPr sz="1800">
+                <a:solidFill>
+                  <a:srgbClr val="323232"/>
+                </a:solidFill>
+              </a:defRPr>
+            </a:pPr>
+            <a:r>
+              <a:t>   DID + Density + Speed</a:t>
             </a:r>
           </a:p>
         </p:txBody>
@@ -7219,18 +6789,18 @@
         </p:nvSpPr>
         <p:spPr>
           <a:xfrm>
-            <a:off x="5943600" y="1371600"/>
-            <a:ext cx="5760720" cy="5029200"/>
+            <a:off x="5943600" y="1188720"/>
+            <a:ext cx="5760720" cy="5303520"/>
           </a:xfrm>
           <a:prstGeom prst="roundRect">
             <a:avLst/>
           </a:prstGeom>
           <a:solidFill>
-            <a:srgbClr val="F0F0F0"/>
+            <a:srgbClr val="F5F5F5"/>
           </a:solidFill>
           <a:ln>
             <a:solidFill>
-              <a:srgbClr val="969696"/>
+              <a:srgbClr val="B4B4B4"/>
             </a:solidFill>
           </a:ln>
         </p:spPr>
@@ -7264,8 +6834,8 @@
         </p:nvSpPr>
         <p:spPr>
           <a:xfrm>
-            <a:off x="6126480" y="1554480"/>
-            <a:ext cx="5394960" cy="4663440"/>
+            <a:off x="6126480" y="1371600"/>
+            <a:ext cx="5394960" cy="4937760"/>
           </a:xfrm>
           <a:prstGeom prst="rect">
             <a:avLst/>
@@ -7347,475 +6917,7 @@
             </a:r>
             <a:br/>
             <a:r>
-              <a:t>│  Remove mismatched series to enable targets.    │</a:t>
-            </a:r>
-            <a:br/>
-            <a:r>
-              <a:t>│                                                 │</a:t>
-            </a:r>
-            <a:br/>
-            <a:r>
               <a:t>└─────────────────────────────────────────────────┘</a:t>
-            </a:r>
-          </a:p>
-        </p:txBody>
-      </p:sp>
-    </p:spTree>
-  </p:cSld>
-  <p:clrMapOvr>
-    <a:masterClrMapping/>
-  </p:clrMapOvr>
-</p:sld>
-</file>
-
-<file path=ppt/slides/slide9.xml><?xml version="1.0" encoding="utf-8"?>
-<p:sld xmlns:a="http://schemas.openxmlformats.org/drawingml/2006/main" xmlns:p="http://schemas.openxmlformats.org/presentationml/2006/main" xmlns:r="http://schemas.openxmlformats.org/officeDocument/2006/relationships">
-  <p:cSld>
-    <p:spTree>
-      <p:nvGrpSpPr>
-        <p:cNvPr id="1" name=""/>
-        <p:cNvGrpSpPr/>
-        <p:nvPr/>
-      </p:nvGrpSpPr>
-      <p:grpSpPr/>
-      <p:sp>
-        <p:nvSpPr>
-          <p:cNvPr id="2" name="Rectangle 1"/>
-          <p:cNvSpPr/>
-          <p:nvPr/>
-        </p:nvSpPr>
-        <p:spPr>
-          <a:xfrm>
-            <a:off x="0" y="0"/>
-            <a:ext cx="12191695" cy="1097280"/>
-          </a:xfrm>
-          <a:prstGeom prst="rect">
-            <a:avLst/>
-          </a:prstGeom>
-          <a:solidFill>
-            <a:srgbClr val="003366"/>
-          </a:solidFill>
-          <a:ln>
-            <a:noFill/>
-          </a:ln>
-        </p:spPr>
-        <p:style>
-          <a:lnRef idx="1">
-            <a:schemeClr val="accent1"/>
-          </a:lnRef>
-          <a:fillRef idx="3">
-            <a:schemeClr val="accent1"/>
-          </a:fillRef>
-          <a:effectRef idx="2">
-            <a:schemeClr val="accent1"/>
-          </a:effectRef>
-          <a:fontRef idx="minor">
-            <a:schemeClr val="lt1"/>
-          </a:fontRef>
-        </p:style>
-        <p:txBody>
-          <a:bodyPr rtlCol="0" anchor="ctr"/>
-          <a:lstStyle/>
-          <a:p>
-            <a:pPr algn="ctr"/>
-          </a:p>
-        </p:txBody>
-      </p:sp>
-      <p:sp>
-        <p:nvSpPr>
-          <p:cNvPr id="3" name="TextBox 2"/>
-          <p:cNvSpPr txBox="1"/>
-          <p:nvPr/>
-        </p:nvSpPr>
-        <p:spPr>
-          <a:xfrm>
-            <a:off x="457200" y="274320"/>
-            <a:ext cx="10972800" cy="731520"/>
-          </a:xfrm>
-          <a:prstGeom prst="rect">
-            <a:avLst/>
-          </a:prstGeom>
-          <a:noFill/>
-        </p:spPr>
-        <p:txBody>
-          <a:bodyPr wrap="none">
-            <a:spAutoFit/>
-          </a:bodyPr>
-          <a:lstStyle/>
-          <a:p>
-            <a:pPr>
-              <a:defRPr sz="3200" b="1">
-                <a:solidFill>
-                  <a:srgbClr val="FFFFFF"/>
-                </a:solidFill>
-              </a:defRPr>
-            </a:pPr>
-            <a:r>
-              <a:t>Example: Complete Workflow</a:t>
-            </a:r>
-          </a:p>
-        </p:txBody>
-      </p:sp>
-      <p:sp>
-        <p:nvSpPr>
-          <p:cNvPr id="4" name="TextBox 3"/>
-          <p:cNvSpPr txBox="1"/>
-          <p:nvPr/>
-        </p:nvSpPr>
-        <p:spPr>
-          <a:xfrm>
-            <a:off x="457200" y="1371600"/>
-            <a:ext cx="5029200" cy="5029200"/>
-          </a:xfrm>
-          <a:prstGeom prst="rect">
-            <a:avLst/>
-          </a:prstGeom>
-          <a:noFill/>
-        </p:spPr>
-        <p:txBody>
-          <a:bodyPr wrap="square">
-            <a:spAutoFit/>
-          </a:bodyPr>
-          <a:lstStyle/>
-          <a:p>
-            <a:pPr>
-              <a:spcAft>
-                <a:spcPts val="1200"/>
-              </a:spcAft>
-              <a:defRPr sz="1800">
-                <a:solidFill>
-                  <a:srgbClr val="323232"/>
-                </a:solidFill>
-              </a:defRPr>
-            </a:pPr>
-            <a:r>
-              <a:t>Goal: View Y6CP 192GB 7500MT</a:t>
-            </a:r>
-          </a:p>
-          <a:p>
-            <a:pPr>
-              <a:spcAft>
-                <a:spcPts val="1200"/>
-              </a:spcAft>
-              <a:defRPr sz="1800">
-                <a:solidFill>
-                  <a:srgbClr val="323232"/>
-                </a:solidFill>
-              </a:defRPr>
-            </a:pPr>
-            <a:r>
-              <a:t>      with D1 projection lines</a:t>
-            </a:r>
-          </a:p>
-          <a:p>
-            <a:pPr>
-              <a:spcAft>
-                <a:spcPts val="1200"/>
-              </a:spcAft>
-              <a:defRPr sz="1800">
-                <a:solidFill>
-                  <a:srgbClr val="323232"/>
-                </a:solidFill>
-              </a:defRPr>
-            </a:pPr>
-          </a:p>
-          <a:p>
-            <a:pPr>
-              <a:spcAft>
-                <a:spcPts val="1200"/>
-              </a:spcAft>
-              <a:defRPr sz="1800">
-                <a:solidFill>
-                  <a:srgbClr val="323232"/>
-                </a:solidFill>
-              </a:defRPr>
-            </a:pPr>
-            <a:r>
-              <a:t>Steps:</a:t>
-            </a:r>
-          </a:p>
-          <a:p>
-            <a:pPr>
-              <a:spcAft>
-                <a:spcPts val="1200"/>
-              </a:spcAft>
-              <a:defRPr sz="1800">
-                <a:solidFill>
-                  <a:srgbClr val="323232"/>
-                </a:solidFill>
-              </a:defRPr>
-            </a:pPr>
-            <a:r>
-              <a:t>1. Set sidebar filters</a:t>
-            </a:r>
-          </a:p>
-          <a:p>
-            <a:pPr>
-              <a:spcAft>
-                <a:spcPts val="1200"/>
-              </a:spcAft>
-              <a:defRPr sz="1800">
-                <a:solidFill>
-                  <a:srgbClr val="323232"/>
-                </a:solidFill>
-              </a:defRPr>
-            </a:pPr>
-            <a:r>
-              <a:t>   (Form, Step, DID, Facility, WW)</a:t>
-            </a:r>
-          </a:p>
-          <a:p>
-            <a:pPr>
-              <a:spcAft>
-                <a:spcPts val="1200"/>
-              </a:spcAft>
-              <a:defRPr sz="1800">
-                <a:solidFill>
-                  <a:srgbClr val="323232"/>
-                </a:solidFill>
-              </a:defRPr>
-            </a:pPr>
-          </a:p>
-          <a:p>
-            <a:pPr>
-              <a:spcAft>
-                <a:spcPts val="1200"/>
-              </a:spcAft>
-              <a:defRPr sz="1800">
-                <a:solidFill>
-                  <a:srgbClr val="323232"/>
-                </a:solidFill>
-              </a:defRPr>
-            </a:pPr>
-            <a:r>
-              <a:t>2. Select ONLY matching series</a:t>
-            </a:r>
-          </a:p>
-          <a:p>
-            <a:pPr>
-              <a:spcAft>
-                <a:spcPts val="1200"/>
-              </a:spcAft>
-              <a:defRPr sz="1800">
-                <a:solidFill>
-                  <a:srgbClr val="323232"/>
-                </a:solidFill>
-              </a:defRPr>
-            </a:pPr>
-            <a:r>
-              <a:t>   (same DID+Density+Speed)</a:t>
-            </a:r>
-          </a:p>
-          <a:p>
-            <a:pPr>
-              <a:spcAft>
-                <a:spcPts val="1200"/>
-              </a:spcAft>
-              <a:defRPr sz="1800">
-                <a:solidFill>
-                  <a:srgbClr val="323232"/>
-                </a:solidFill>
-              </a:defRPr>
-            </a:pPr>
-          </a:p>
-          <a:p>
-            <a:pPr>
-              <a:spcAft>
-                <a:spcPts val="1200"/>
-              </a:spcAft>
-              <a:defRPr sz="1800">
-                <a:solidFill>
-                  <a:srgbClr val="323232"/>
-                </a:solidFill>
-              </a:defRPr>
-            </a:pPr>
-            <a:r>
-              <a:t>3. Enable 'Show D1 Target Lines'</a:t>
-            </a:r>
-          </a:p>
-          <a:p>
-            <a:pPr>
-              <a:spcAft>
-                <a:spcPts val="1200"/>
-              </a:spcAft>
-              <a:defRPr sz="1800">
-                <a:solidFill>
-                  <a:srgbClr val="323232"/>
-                </a:solidFill>
-              </a:defRPr>
-            </a:pPr>
-          </a:p>
-          <a:p>
-            <a:pPr>
-              <a:spcAft>
-                <a:spcPts val="1200"/>
-              </a:spcAft>
-              <a:defRPr sz="1800">
-                <a:solidFill>
-                  <a:srgbClr val="323232"/>
-                </a:solidFill>
-              </a:defRPr>
-            </a:pPr>
-            <a:r>
-              <a:t>4. Review chart comparison</a:t>
-            </a:r>
-          </a:p>
-        </p:txBody>
-      </p:sp>
-      <p:sp>
-        <p:nvSpPr>
-          <p:cNvPr id="5" name="Rounded Rectangle 4"/>
-          <p:cNvSpPr/>
-          <p:nvPr/>
-        </p:nvSpPr>
-        <p:spPr>
-          <a:xfrm>
-            <a:off x="5943600" y="1371600"/>
-            <a:ext cx="5760720" cy="5029200"/>
-          </a:xfrm>
-          <a:prstGeom prst="roundRect">
-            <a:avLst/>
-          </a:prstGeom>
-          <a:solidFill>
-            <a:srgbClr val="F0F0F0"/>
-          </a:solidFill>
-          <a:ln>
-            <a:solidFill>
-              <a:srgbClr val="969696"/>
-            </a:solidFill>
-          </a:ln>
-        </p:spPr>
-        <p:style>
-          <a:lnRef idx="1">
-            <a:schemeClr val="accent1"/>
-          </a:lnRef>
-          <a:fillRef idx="3">
-            <a:schemeClr val="accent1"/>
-          </a:fillRef>
-          <a:effectRef idx="2">
-            <a:schemeClr val="accent1"/>
-          </a:effectRef>
-          <a:fontRef idx="minor">
-            <a:schemeClr val="lt1"/>
-          </a:fontRef>
-        </p:style>
-        <p:txBody>
-          <a:bodyPr rtlCol="0" anchor="ctr"/>
-          <a:lstStyle/>
-          <a:p>
-            <a:pPr algn="ctr"/>
-          </a:p>
-        </p:txBody>
-      </p:sp>
-      <p:sp>
-        <p:nvSpPr>
-          <p:cNvPr id="6" name="TextBox 5"/>
-          <p:cNvSpPr txBox="1"/>
-          <p:nvPr/>
-        </p:nvSpPr>
-        <p:spPr>
-          <a:xfrm>
-            <a:off x="6126480" y="1554480"/>
-            <a:ext cx="5394960" cy="4663440"/>
-          </a:xfrm>
-          <a:prstGeom prst="rect">
-            <a:avLst/>
-          </a:prstGeom>
-          <a:noFill/>
-        </p:spPr>
-        <p:txBody>
-          <a:bodyPr wrap="square">
-            <a:spAutoFit/>
-          </a:bodyPr>
-          <a:lstStyle/>
-          <a:p>
-            <a:pPr>
-              <a:defRPr sz="1000">
-                <a:solidFill>
-                  <a:srgbClr val="323232"/>
-                </a:solidFill>
-                <a:latin typeface="Courier New"/>
-              </a:defRPr>
-            </a:pPr>
-            <a:r>
-              <a:t>GOAL: View Y6CP 192GB 7500MTPS with targets</a:t>
-            </a:r>
-            <a:br/>
-            <a:br/>
-            <a:r>
-              <a:t>┌─ SIDEBAR ──────────────────────────────────────┐</a:t>
-            </a:r>
-            <a:br/>
-            <a:r>
-              <a:t>│ Form Factor: [✓] SOCAMM2                       │</a:t>
-            </a:r>
-            <a:br/>
-            <a:r>
-              <a:t>│ Test Step:   [✓] HMFN [✓] HMB1 [✓] QMON        │</a:t>
-            </a:r>
-            <a:br/>
-            <a:r>
-              <a:t>│ Design ID:   [✓] Y6CP                          │</a:t>
-            </a:r>
-            <a:br/>
-            <a:r>
-              <a:t>│ Facility:    [✓] PENANG                        │</a:t>
-            </a:r>
-            <a:br/>
-            <a:r>
-              <a:t>│ Work Week:   2026 WW06-WW15                    │</a:t>
-            </a:r>
-            <a:br/>
-            <a:r>
-              <a:t>└────────────────────────────────────────────────┘</a:t>
-            </a:r>
-            <a:br/>
-            <a:r>
-              <a:t>           ↓</a:t>
-            </a:r>
-            <a:br/>
-            <a:r>
-              <a:t>┌─ SERIES SELECTOR ──────────────────────────────┐</a:t>
-            </a:r>
-            <a:br/>
-            <a:r>
-              <a:t>│ [✓] Y6CP_SOCAMM2_192GB_7500MTPS_HMFN          │</a:t>
-            </a:r>
-            <a:br/>
-            <a:r>
-              <a:t>│ [✓] Y6CP_SOCAMM2_192GB_7500MTPS_SLT           │</a:t>
-            </a:r>
-            <a:br/>
-            <a:r>
-              <a:t>│ [✓] Y6CP_SOCAMM2_192GB_7500MTPS_ELC           │</a:t>
-            </a:r>
-            <a:br/>
-            <a:r>
-              <a:t>│ [ ] Y6CP_SOCAMM2_96GB_9600MTPS_HMFN           │</a:t>
-            </a:r>
-            <a:br/>
-            <a:r>
-              <a:t>│ [ ] ... (other configs unchecked)              │</a:t>
-            </a:r>
-            <a:br/>
-            <a:r>
-              <a:t>└────────────────────────────────────────────────┘</a:t>
-            </a:r>
-            <a:br/>
-            <a:r>
-              <a:t>           ↓</a:t>
-            </a:r>
-            <a:br/>
-            <a:r>
-              <a:t>┌─ ENABLE TARGETS ───────────────────────────────┐</a:t>
-            </a:r>
-            <a:br/>
-            <a:r>
-              <a:t>│ [✓] Show D1 Target Lines  ← Check this!        │</a:t>
-            </a:r>
-            <a:br/>
-            <a:r>
-              <a:t>└────────────────────────────────────────────────┘</a:t>
             </a:r>
           </a:p>
         </p:txBody>

</xml_diff>